<commit_message>
US482 Task484: Added web scraper section and some pictures.
</commit_message>
<xml_diff>
--- a/Team 32 Innovation Showcase Poster.pptx
+++ b/Team 32 Innovation Showcase Poster.pptx
@@ -2,13 +2,13 @@
 <file path=ppt/presentation.xml><?xml version="1.0" encoding="utf-8"?>
 <p:presentation xmlns:a="http://schemas.openxmlformats.org/drawingml/2006/main" xmlns:r="http://schemas.openxmlformats.org/officeDocument/2006/relationships" xmlns:mc="http://schemas.openxmlformats.org/markup-compatibility/2006" xmlns:mv="urn:schemas-microsoft-com:mac:vml" xmlns:p="http://schemas.openxmlformats.org/presentationml/2006/main" xmlns:c="http://schemas.openxmlformats.org/drawingml/2006/chart" xmlns:dgm="http://schemas.openxmlformats.org/drawingml/2006/diagram" xmlns:o="urn:schemas-microsoft-com:office:office" xmlns:v="urn:schemas-microsoft-com:vml" xmlns:pvml="urn:schemas-microsoft-com:office:powerpoint" xmlns:com="http://schemas.openxmlformats.org/drawingml/2006/compatibility" xmlns:p14="http://schemas.microsoft.com/office/powerpoint/2010/main" xmlns:p15="http://schemas.microsoft.com/office/powerpoint/2012/main" xmlns:ahyp="http://schemas.microsoft.com/office/drawing/2018/hyperlinkcolor" autoCompressPictures="0" strictFirstAndLastChars="0" saveSubsetFonts="1">
   <p:sldMasterIdLst>
-    <p:sldMasterId id="2147483648" r:id="rId5"/>
+    <p:sldMasterId id="2147483648" r:id="rId4"/>
   </p:sldMasterIdLst>
   <p:notesMasterIdLst>
-    <p:notesMasterId r:id="rId6"/>
+    <p:notesMasterId r:id="rId5"/>
   </p:notesMasterIdLst>
   <p:sldIdLst>
-    <p:sldId id="256" r:id="rId7"/>
+    <p:sldId id="256" r:id="rId6"/>
   </p:sldIdLst>
   <p:sldSz cy="21031200" cx="32004000"/>
   <p:notesSz cx="6858000" cy="9144000"/>
@@ -257,33 +257,10 @@
       </p15:sldGuideLst>
     </p:ext>
     <p:ext uri="GoogleSlidesCustomDataVersion2">
-      <go:slidesCustomData xmlns:go="http://customooxmlschemas.google.com/" r:id="rId8" roundtripDataSignature="AMtx7mg+kE06d6c0Ui/U0Nnye+Tt4xm0ew=="/>
+      <go:slidesCustomData xmlns:go="http://customooxmlschemas.google.com/" r:id="rId7" roundtripDataSignature="AMtx7mgqw4verhR8mXoJd3+pxlrBKF7zFw=="/>
     </p:ext>
   </p:extLst>
 </p:presentation>
-</file>
-
-<file path=ppt/commentAuthors.xml><?xml version="1.0" encoding="utf-8"?>
-<p:cmAuthorLst xmlns:a="http://schemas.openxmlformats.org/drawingml/2006/main" xmlns:r="http://schemas.openxmlformats.org/officeDocument/2006/relationships" xmlns:mc="http://schemas.openxmlformats.org/markup-compatibility/2006" xmlns:mv="urn:schemas-microsoft-com:mac:vml" xmlns:p="http://schemas.openxmlformats.org/presentationml/2006/main" xmlns:c="http://schemas.openxmlformats.org/drawingml/2006/chart" xmlns:dgm="http://schemas.openxmlformats.org/drawingml/2006/diagram" xmlns:o="urn:schemas-microsoft-com:office:office" xmlns:v="urn:schemas-microsoft-com:vml" xmlns:pvml="urn:schemas-microsoft-com:office:powerpoint" xmlns:com="http://schemas.openxmlformats.org/drawingml/2006/compatibility" xmlns:p14="http://schemas.microsoft.com/office/powerpoint/2010/main" xmlns:p15="http://schemas.microsoft.com/office/powerpoint/2012/main" xmlns:ahyp="http://schemas.microsoft.com/office/drawing/2018/hyperlinkcolor">
-  <p:cmAuthor clrIdx="0" id="0" initials="" lastIdx="1" name="Emily Sanders"/>
-</p:cmAuthorLst>
-</file>
-
-<file path=ppt/comments/comment1.xml><?xml version="1.0" encoding="utf-8"?>
-<p:cmLst xmlns:a="http://schemas.openxmlformats.org/drawingml/2006/main" xmlns:r="http://schemas.openxmlformats.org/officeDocument/2006/relationships" xmlns:mc="http://schemas.openxmlformats.org/markup-compatibility/2006" xmlns:mv="urn:schemas-microsoft-com:mac:vml" xmlns:p="http://schemas.openxmlformats.org/presentationml/2006/main" xmlns:c="http://schemas.openxmlformats.org/drawingml/2006/chart" xmlns:dgm="http://schemas.openxmlformats.org/drawingml/2006/diagram" xmlns:o="urn:schemas-microsoft-com:office:office" xmlns:v="urn:schemas-microsoft-com:vml" xmlns:pvml="urn:schemas-microsoft-com:office:powerpoint" xmlns:com="http://schemas.openxmlformats.org/drawingml/2006/compatibility" xmlns:p14="http://schemas.microsoft.com/office/powerpoint/2010/main" xmlns:p15="http://schemas.microsoft.com/office/powerpoint/2012/main" xmlns:ahyp="http://schemas.microsoft.com/office/drawing/2018/hyperlinkcolor">
-  <p:cm authorId="0" idx="1" dt="2026-04-14T01:10:01.613">
-    <p:pos x="6000" y="0"/>
-    <p:text>Will probably change text size later</p:text>
-    <p:extLst>
-      <p:ext uri="{C676402C-5697-4E1C-873F-D02D1690AC5C}">
-        <p15:threadingInfo timeZoneBias="0"/>
-      </p:ext>
-      <p:ext uri="http://customooxmlschemas.google.com/">
-        <go:slidesCustomData xmlns:go="http://customooxmlschemas.google.com/" commentPostId="AAAB3QdqHCM"/>
-      </p:ext>
-    </p:extLst>
-  </p:cm>
-</p:cmLst>
 </file>
 
 <file path=ppt/notesMasters/notesMaster1.xml><?xml version="1.0" encoding="utf-8"?>
@@ -13261,7 +13238,7 @@
           <p:nvPr/>
         </p:nvPicPr>
         <p:blipFill rotWithShape="1">
-          <a:blip r:embed="rId4">
+          <a:blip r:embed="rId3">
             <a:alphaModFix/>
           </a:blip>
           <a:srcRect b="0" l="0" r="0" t="0"/>
@@ -13288,7 +13265,7 @@
           <p:nvPr/>
         </p:nvPicPr>
         <p:blipFill>
-          <a:blip r:embed="rId5">
+          <a:blip r:embed="rId4">
             <a:alphaModFix/>
           </a:blip>
           <a:stretch>
@@ -13375,26 +13352,22 @@
         </p:nvSpPr>
         <p:spPr>
           <a:xfrm>
-            <a:off x="11588650" y="13994350"/>
-            <a:ext cx="8924400" cy="6407400"/>
+            <a:off x="11288250" y="4055850"/>
+            <a:ext cx="9427500" cy="6095400"/>
           </a:xfrm>
           <a:prstGeom prst="rect">
             <a:avLst/>
           </a:prstGeom>
-          <a:noFill/>
-          <a:ln cap="flat" cmpd="sng" w="9525">
-            <a:solidFill>
-              <a:srgbClr val="000000"/>
-            </a:solidFill>
-            <a:prstDash val="solid"/>
-            <a:round/>
-            <a:headEnd len="sm" w="sm" type="none"/>
-            <a:tailEnd len="sm" w="sm" type="none"/>
+          <a:solidFill>
+            <a:srgbClr val="F9A000"/>
+          </a:solidFill>
+          <a:ln>
+            <a:noFill/>
           </a:ln>
         </p:spPr>
         <p:txBody>
           <a:bodyPr anchorCtr="0" anchor="t" bIns="91425" lIns="91425" spcFirstLastPara="1" rIns="91425" wrap="square" tIns="91425">
-            <a:noAutofit/>
+            <a:spAutoFit/>
           </a:bodyPr>
           <a:lstStyle/>
           <a:p>
@@ -13408,7 +13381,7 @@
               <a:buNone/>
             </a:pPr>
             <a:r>
-              <a:rPr lang="en-US" sz="10600">
+              <a:rPr lang="en-US" sz="4800">
                 <a:solidFill>
                   <a:schemeClr val="dk1"/>
                 </a:solidFill>
@@ -13417,9 +13390,65 @@
                 <a:cs typeface="Calibri"/>
                 <a:sym typeface="Calibri"/>
               </a:rPr>
-              <a:t>Picture?</a:t>
+              <a:t>Web Scraper</a:t>
             </a:r>
-            <a:endParaRPr sz="10600">
+            <a:endParaRPr sz="4800">
+              <a:solidFill>
+                <a:schemeClr val="dk1"/>
+              </a:solidFill>
+              <a:latin typeface="Calibri"/>
+              <a:ea typeface="Calibri"/>
+              <a:cs typeface="Calibri"/>
+              <a:sym typeface="Calibri"/>
+            </a:endParaRPr>
+          </a:p>
+          <a:p>
+            <a:pPr indent="0" lvl="0" marL="0" rtl="0" algn="l">
+              <a:spcBef>
+                <a:spcPts val="0"/>
+              </a:spcBef>
+              <a:spcAft>
+                <a:spcPts val="0"/>
+              </a:spcAft>
+              <a:buNone/>
+            </a:pPr>
+            <a:r>
+              <a:rPr lang="en-US" sz="2400">
+                <a:solidFill>
+                  <a:schemeClr val="dk1"/>
+                </a:solidFill>
+                <a:latin typeface="Calibri"/>
+                <a:ea typeface="Calibri"/>
+                <a:cs typeface="Calibri"/>
+                <a:sym typeface="Calibri"/>
+              </a:rPr>
+              <a:t>The </a:t>
+            </a:r>
+            <a:r>
+              <a:rPr lang="en-US" sz="2400">
+                <a:solidFill>
+                  <a:schemeClr val="dk1"/>
+                </a:solidFill>
+                <a:latin typeface="Calibri"/>
+                <a:ea typeface="Calibri"/>
+                <a:cs typeface="Calibri"/>
+                <a:sym typeface="Calibri"/>
+              </a:rPr>
+              <a:t>media</a:t>
+            </a:r>
+            <a:r>
+              <a:rPr lang="en-US" sz="2400">
+                <a:solidFill>
+                  <a:schemeClr val="dk1"/>
+                </a:solidFill>
+                <a:latin typeface="Calibri"/>
+                <a:ea typeface="Calibri"/>
+                <a:cs typeface="Calibri"/>
+                <a:sym typeface="Calibri"/>
+              </a:rPr>
+              <a:t> files for the Psyche Inspired projects are hosted on a NASA website.  All of these files must be downloaded and stored locally in order to appear in the museum.  Our team created a CSV table that storing the information about each project (title, artist, medium, etc.) as well as the link to the project’s page on the NASA website.  The webscraper, which is set up in Docker for user ease, visits the webpage and downloads the project media files, whether that be an image, a YouTube video, or a gif.  It then stores these media files along with their associated project information in a local database.  When this database has been populated, the Unity VR program is able to read from the database and populate art frames on the museum walls with the images.  A small plaque to the side of the frame holds the basic art and artist information.  Clicking a button next to the plaque expands it to show the full artist’s description of the work.</a:t>
+            </a:r>
+            <a:endParaRPr sz="2400">
               <a:solidFill>
                 <a:schemeClr val="dk1"/>
               </a:solidFill>
@@ -13440,7 +13469,7 @@
         <p:spPr>
           <a:xfrm>
             <a:off x="899050" y="11246825"/>
-            <a:ext cx="9544500" cy="3509400"/>
+            <a:ext cx="9427500" cy="3509400"/>
           </a:xfrm>
           <a:prstGeom prst="rect">
             <a:avLst/>
@@ -13526,98 +13555,6 @@
       <p:sp>
         <p:nvSpPr>
           <p:cNvPr id="90" name="Google Shape;90;p1"/>
-          <p:cNvSpPr txBox="1"/>
-          <p:nvPr/>
-        </p:nvSpPr>
-        <p:spPr>
-          <a:xfrm>
-            <a:off x="11288250" y="4055850"/>
-            <a:ext cx="9427500" cy="3694200"/>
-          </a:xfrm>
-          <a:prstGeom prst="rect">
-            <a:avLst/>
-          </a:prstGeom>
-          <a:solidFill>
-            <a:srgbClr val="F9A000"/>
-          </a:solidFill>
-          <a:ln>
-            <a:noFill/>
-          </a:ln>
-        </p:spPr>
-        <p:txBody>
-          <a:bodyPr anchorCtr="0" anchor="t" bIns="91425" lIns="91425" spcFirstLastPara="1" rIns="91425" wrap="square" tIns="91425">
-            <a:spAutoFit/>
-          </a:bodyPr>
-          <a:lstStyle/>
-          <a:p>
-            <a:pPr indent="0" lvl="0" marL="0" rtl="0" algn="l">
-              <a:spcBef>
-                <a:spcPts val="0"/>
-              </a:spcBef>
-              <a:spcAft>
-                <a:spcPts val="0"/>
-              </a:spcAft>
-              <a:buNone/>
-            </a:pPr>
-            <a:r>
-              <a:rPr lang="en-US" sz="6000">
-                <a:solidFill>
-                  <a:schemeClr val="dk1"/>
-                </a:solidFill>
-                <a:latin typeface="Calibri"/>
-                <a:ea typeface="Calibri"/>
-                <a:cs typeface="Calibri"/>
-                <a:sym typeface="Calibri"/>
-              </a:rPr>
-              <a:t>Web Scraper</a:t>
-            </a:r>
-            <a:endParaRPr sz="3600">
-              <a:solidFill>
-                <a:schemeClr val="dk1"/>
-              </a:solidFill>
-              <a:latin typeface="Calibri"/>
-              <a:ea typeface="Calibri"/>
-              <a:cs typeface="Calibri"/>
-              <a:sym typeface="Calibri"/>
-            </a:endParaRPr>
-          </a:p>
-          <a:p>
-            <a:pPr indent="0" lvl="0" marL="0" rtl="0" algn="l">
-              <a:spcBef>
-                <a:spcPts val="0"/>
-              </a:spcBef>
-              <a:spcAft>
-                <a:spcPts val="0"/>
-              </a:spcAft>
-              <a:buNone/>
-            </a:pPr>
-            <a:r>
-              <a:rPr lang="en-US" sz="2400">
-                <a:solidFill>
-                  <a:schemeClr val="dk1"/>
-                </a:solidFill>
-                <a:latin typeface="Calibri"/>
-                <a:ea typeface="Calibri"/>
-                <a:cs typeface="Calibri"/>
-                <a:sym typeface="Calibri"/>
-              </a:rPr>
-              <a:t>Lorem ipsum dolor sit amet, consectetur adipiscing elit, sed do eiusmod tempor incididunt ut labore et dolore magna aliqua. Ut enim ad minim veniam, quis nostrud exercitation ullamco laboris nisi ut aliquip ex ea commodo consequat. Duis aute irure dolor in reprehenderit in voluptate velit esse cillum dolore eu fugiat nulla pariatur. Excepteur sint occaecat cupidatat non proident, sunt in culpa qui officia deserunt mollit anim id est laborum.</a:t>
-            </a:r>
-            <a:endParaRPr sz="2400">
-              <a:solidFill>
-                <a:schemeClr val="dk1"/>
-              </a:solidFill>
-              <a:latin typeface="Calibri"/>
-              <a:ea typeface="Calibri"/>
-              <a:cs typeface="Calibri"/>
-              <a:sym typeface="Calibri"/>
-            </a:endParaRPr>
-          </a:p>
-        </p:txBody>
-      </p:sp>
-      <p:sp>
-        <p:nvSpPr>
-          <p:cNvPr id="91" name="Google Shape;91;p1"/>
           <p:cNvSpPr txBox="1"/>
           <p:nvPr/>
         </p:nvSpPr>
@@ -13709,71 +13646,7 @@
       </p:sp>
       <p:sp>
         <p:nvSpPr>
-          <p:cNvPr id="92" name="Google Shape;92;p1"/>
-          <p:cNvSpPr txBox="1"/>
-          <p:nvPr/>
-        </p:nvSpPr>
-        <p:spPr>
-          <a:xfrm>
-            <a:off x="20978050" y="13994350"/>
-            <a:ext cx="8924400" cy="6407400"/>
-          </a:xfrm>
-          <a:prstGeom prst="rect">
-            <a:avLst/>
-          </a:prstGeom>
-          <a:noFill/>
-          <a:ln cap="flat" cmpd="sng" w="9525">
-            <a:solidFill>
-              <a:srgbClr val="000000"/>
-            </a:solidFill>
-            <a:prstDash val="solid"/>
-            <a:round/>
-            <a:headEnd len="sm" w="sm" type="none"/>
-            <a:tailEnd len="sm" w="sm" type="none"/>
-          </a:ln>
-        </p:spPr>
-        <p:txBody>
-          <a:bodyPr anchorCtr="0" anchor="t" bIns="91425" lIns="91425" spcFirstLastPara="1" rIns="91425" wrap="square" tIns="91425">
-            <a:noAutofit/>
-          </a:bodyPr>
-          <a:lstStyle/>
-          <a:p>
-            <a:pPr indent="0" lvl="0" marL="0" rtl="0" algn="l">
-              <a:spcBef>
-                <a:spcPts val="0"/>
-              </a:spcBef>
-              <a:spcAft>
-                <a:spcPts val="0"/>
-              </a:spcAft>
-              <a:buNone/>
-            </a:pPr>
-            <a:r>
-              <a:rPr lang="en-US" sz="10600">
-                <a:solidFill>
-                  <a:schemeClr val="dk1"/>
-                </a:solidFill>
-                <a:latin typeface="Calibri"/>
-                <a:ea typeface="Calibri"/>
-                <a:cs typeface="Calibri"/>
-                <a:sym typeface="Calibri"/>
-              </a:rPr>
-              <a:t>Picture?</a:t>
-            </a:r>
-            <a:endParaRPr sz="10600">
-              <a:solidFill>
-                <a:schemeClr val="dk1"/>
-              </a:solidFill>
-              <a:latin typeface="Calibri"/>
-              <a:ea typeface="Calibri"/>
-              <a:cs typeface="Calibri"/>
-              <a:sym typeface="Calibri"/>
-            </a:endParaRPr>
-          </a:p>
-        </p:txBody>
-      </p:sp>
-      <p:sp>
-        <p:nvSpPr>
-          <p:cNvPr id="93" name="Google Shape;93;p1"/>
+          <p:cNvPr id="91" name="Google Shape;91;p1"/>
           <p:cNvSpPr txBox="1"/>
           <p:nvPr/>
         </p:nvSpPr>
@@ -13839,7 +13712,7 @@
                 <a:uFill>
                   <a:noFill/>
                 </a:uFill>
-                <a:hlinkClick r:id="rId6">
+                <a:hlinkClick r:id="rId5">
                   <a:extLst>
                     <a:ext uri="{A12FA001-AC4F-418D-AE19-62706E023703}">
                       <ahyp:hlinkClr val="tx"/>
@@ -13871,13 +13744,13 @@
       </p:sp>
       <p:sp>
         <p:nvSpPr>
-          <p:cNvPr id="94" name="Google Shape;94;p1"/>
+          <p:cNvPr id="92" name="Google Shape;92;p1"/>
           <p:cNvSpPr txBox="1"/>
           <p:nvPr/>
         </p:nvSpPr>
         <p:spPr>
           <a:xfrm>
-            <a:off x="957550" y="4059761"/>
+            <a:off x="957550" y="4059750"/>
             <a:ext cx="9427500" cy="6464700"/>
           </a:xfrm>
           <a:prstGeom prst="rect">
@@ -13993,82 +13866,88 @@
           </a:p>
         </p:txBody>
       </p:sp>
-      <p:sp>
-        <p:nvSpPr>
-          <p:cNvPr id="95" name="Google Shape;95;p1"/>
-          <p:cNvSpPr txBox="1"/>
+      <p:pic>
+        <p:nvPicPr>
+          <p:cNvPr id="93" name="Google Shape;93;p1"/>
+          <p:cNvPicPr preferRelativeResize="0"/>
           <p:nvPr/>
-        </p:nvSpPr>
+        </p:nvPicPr>
+        <p:blipFill>
+          <a:blip r:embed="rId6">
+            <a:alphaModFix/>
+          </a:blip>
+          <a:stretch>
+            <a:fillRect/>
+          </a:stretch>
+        </p:blipFill>
         <p:spPr>
           <a:xfrm>
-            <a:off x="1150600" y="15478600"/>
-            <a:ext cx="8924400" cy="2869200"/>
+            <a:off x="21618952" y="7977000"/>
+            <a:ext cx="9427500" cy="3753233"/>
           </a:xfrm>
           <a:prstGeom prst="rect">
             <a:avLst/>
           </a:prstGeom>
           <a:noFill/>
-          <a:ln cap="flat" cmpd="sng" w="9525">
-            <a:solidFill>
-              <a:srgbClr val="000000"/>
-            </a:solidFill>
-            <a:prstDash val="solid"/>
-            <a:round/>
-            <a:headEnd len="sm" w="sm" type="none"/>
-            <a:tailEnd len="sm" w="sm" type="none"/>
+          <a:ln>
+            <a:noFill/>
           </a:ln>
         </p:spPr>
-        <p:txBody>
-          <a:bodyPr anchorCtr="0" anchor="t" bIns="91425" lIns="91425" spcFirstLastPara="1" rIns="91425" wrap="square" tIns="91425">
-            <a:noAutofit/>
-          </a:bodyPr>
-          <a:lstStyle/>
-          <a:p>
-            <a:pPr indent="0" lvl="0" marL="0" rtl="0" algn="l">
-              <a:spcBef>
-                <a:spcPts val="0"/>
-              </a:spcBef>
-              <a:spcAft>
-                <a:spcPts val="0"/>
-              </a:spcAft>
-              <a:buNone/>
-            </a:pPr>
-            <a:r>
-              <a:rPr lang="en-US" sz="10600">
-                <a:solidFill>
-                  <a:schemeClr val="dk1"/>
-                </a:solidFill>
-                <a:latin typeface="Calibri"/>
-                <a:ea typeface="Calibri"/>
-                <a:cs typeface="Calibri"/>
-                <a:sym typeface="Calibri"/>
-              </a:rPr>
-              <a:t>Small p</a:t>
-            </a:r>
-            <a:r>
-              <a:rPr lang="en-US" sz="10600">
-                <a:solidFill>
-                  <a:schemeClr val="dk1"/>
-                </a:solidFill>
-                <a:latin typeface="Calibri"/>
-                <a:ea typeface="Calibri"/>
-                <a:cs typeface="Calibri"/>
-                <a:sym typeface="Calibri"/>
-              </a:rPr>
-              <a:t>icture?</a:t>
-            </a:r>
-            <a:endParaRPr sz="10600">
-              <a:solidFill>
-                <a:schemeClr val="dk1"/>
-              </a:solidFill>
-              <a:latin typeface="Calibri"/>
-              <a:ea typeface="Calibri"/>
-              <a:cs typeface="Calibri"/>
-              <a:sym typeface="Calibri"/>
-            </a:endParaRPr>
-          </a:p>
-        </p:txBody>
-      </p:sp>
+      </p:pic>
+      <p:pic>
+        <p:nvPicPr>
+          <p:cNvPr id="94" name="Google Shape;94;p1"/>
+          <p:cNvPicPr preferRelativeResize="0"/>
+          <p:nvPr/>
+        </p:nvPicPr>
+        <p:blipFill rotWithShape="1">
+          <a:blip r:embed="rId7">
+            <a:alphaModFix/>
+          </a:blip>
+          <a:srcRect b="0" l="0" r="3223" t="0"/>
+          <a:stretch/>
+        </p:blipFill>
+        <p:spPr>
+          <a:xfrm>
+            <a:off x="21716650" y="14483963"/>
+            <a:ext cx="9427500" cy="5428176"/>
+          </a:xfrm>
+          <a:prstGeom prst="rect">
+            <a:avLst/>
+          </a:prstGeom>
+          <a:noFill/>
+          <a:ln>
+            <a:noFill/>
+          </a:ln>
+        </p:spPr>
+      </p:pic>
+      <p:pic>
+        <p:nvPicPr>
+          <p:cNvPr id="95" name="Google Shape;95;p1"/>
+          <p:cNvPicPr preferRelativeResize="0"/>
+          <p:nvPr/>
+        </p:nvPicPr>
+        <p:blipFill rotWithShape="1">
+          <a:blip r:embed="rId8">
+            <a:alphaModFix/>
+          </a:blip>
+          <a:srcRect b="4934" l="0" r="1778" t="0"/>
+          <a:stretch/>
+        </p:blipFill>
+        <p:spPr>
+          <a:xfrm>
+            <a:off x="12746238" y="13425800"/>
+            <a:ext cx="6609225" cy="6975950"/>
+          </a:xfrm>
+          <a:prstGeom prst="rect">
+            <a:avLst/>
+          </a:prstGeom>
+          <a:noFill/>
+          <a:ln>
+            <a:noFill/>
+          </a:ln>
+        </p:spPr>
+      </p:pic>
     </p:spTree>
   </p:cSld>
   <p:clrMapOvr>
@@ -14078,6 +13957,285 @@
 </file>
 
 <file path=ppt/theme/theme1.xml><?xml version="1.0" encoding="utf-8"?>
+<a:theme xmlns:a="http://schemas.openxmlformats.org/drawingml/2006/main" xmlns:r="http://schemas.openxmlformats.org/officeDocument/2006/relationships" name="Office Theme">
+  <a:themeElements>
+    <a:clrScheme name="Office">
+      <a:dk1>
+        <a:srgbClr val="000000"/>
+      </a:dk1>
+      <a:lt1>
+        <a:srgbClr val="FFFFFF"/>
+      </a:lt1>
+      <a:dk2>
+        <a:srgbClr val="1F497D"/>
+      </a:dk2>
+      <a:lt2>
+        <a:srgbClr val="EEECE1"/>
+      </a:lt2>
+      <a:accent1>
+        <a:srgbClr val="4F81BD"/>
+      </a:accent1>
+      <a:accent2>
+        <a:srgbClr val="C0504D"/>
+      </a:accent2>
+      <a:accent3>
+        <a:srgbClr val="9BBB59"/>
+      </a:accent3>
+      <a:accent4>
+        <a:srgbClr val="8064A2"/>
+      </a:accent4>
+      <a:accent5>
+        <a:srgbClr val="4BACC6"/>
+      </a:accent5>
+      <a:accent6>
+        <a:srgbClr val="F79646"/>
+      </a:accent6>
+      <a:hlink>
+        <a:srgbClr val="0000FF"/>
+      </a:hlink>
+      <a:folHlink>
+        <a:srgbClr val="800080"/>
+      </a:folHlink>
+    </a:clrScheme>
+    <a:fontScheme name="Office">
+      <a:majorFont>
+        <a:latin typeface="Arial"/>
+        <a:ea typeface=""/>
+        <a:cs typeface=""/>
+        <a:font script="Jpan" typeface="ＭＳ Ｐゴシック"/>
+        <a:font script="Hang" typeface="맑은 고딕"/>
+        <a:font script="Hans" typeface="宋体"/>
+        <a:font script="Hant" typeface="新細明體"/>
+        <a:font script="Arab" typeface="Times New Roman"/>
+        <a:font script="Hebr" typeface="Times New Roman"/>
+        <a:font script="Thai" typeface="Angsana New"/>
+        <a:font script="Ethi" typeface="Nyala"/>
+        <a:font script="Beng" typeface="Vrinda"/>
+        <a:font script="Gujr" typeface="Shruti"/>
+        <a:font script="Khmr" typeface="MoolBoran"/>
+        <a:font script="Knda" typeface="Tunga"/>
+        <a:font script="Guru" typeface="Raavi"/>
+        <a:font script="Cans" typeface="Euphemia"/>
+        <a:font script="Cher" typeface="Plantagenet Cherokee"/>
+        <a:font script="Yiii" typeface="Microsoft Yi Baiti"/>
+        <a:font script="Tibt" typeface="Microsoft Himalaya"/>
+        <a:font script="Thaa" typeface="MV Boli"/>
+        <a:font script="Deva" typeface="Mangal"/>
+        <a:font script="Telu" typeface="Gautami"/>
+        <a:font script="Taml" typeface="Latha"/>
+        <a:font script="Syrc" typeface="Estrangelo Edessa"/>
+        <a:font script="Orya" typeface="Kalinga"/>
+        <a:font script="Mlym" typeface="Kartika"/>
+        <a:font script="Laoo" typeface="DokChampa"/>
+        <a:font script="Sinh" typeface="Iskoola Pota"/>
+        <a:font script="Mong" typeface="Mongolian Baiti"/>
+        <a:font script="Viet" typeface="Times New Roman"/>
+        <a:font script="Uigh" typeface="Microsoft Uighur"/>
+        <a:font script="Geor" typeface="Sylfaen"/>
+      </a:majorFont>
+      <a:minorFont>
+        <a:latin typeface="Arial"/>
+        <a:ea typeface=""/>
+        <a:cs typeface=""/>
+        <a:font script="Jpan" typeface="ＭＳ Ｐゴシック"/>
+        <a:font script="Hang" typeface="맑은 고딕"/>
+        <a:font script="Hans" typeface="宋体"/>
+        <a:font script="Hant" typeface="新細明體"/>
+        <a:font script="Arab" typeface="Arial"/>
+        <a:font script="Hebr" typeface="Arial"/>
+        <a:font script="Thai" typeface="Cordia New"/>
+        <a:font script="Ethi" typeface="Nyala"/>
+        <a:font script="Beng" typeface="Vrinda"/>
+        <a:font script="Gujr" typeface="Shruti"/>
+        <a:font script="Khmr" typeface="DaunPenh"/>
+        <a:font script="Knda" typeface="Tunga"/>
+        <a:font script="Guru" typeface="Raavi"/>
+        <a:font script="Cans" typeface="Euphemia"/>
+        <a:font script="Cher" typeface="Plantagenet Cherokee"/>
+        <a:font script="Yiii" typeface="Microsoft Yi Baiti"/>
+        <a:font script="Tibt" typeface="Microsoft Himalaya"/>
+        <a:font script="Thaa" typeface="MV Boli"/>
+        <a:font script="Deva" typeface="Mangal"/>
+        <a:font script="Telu" typeface="Gautami"/>
+        <a:font script="Taml" typeface="Latha"/>
+        <a:font script="Syrc" typeface="Estrangelo Edessa"/>
+        <a:font script="Orya" typeface="Kalinga"/>
+        <a:font script="Mlym" typeface="Kartika"/>
+        <a:font script="Laoo" typeface="DokChampa"/>
+        <a:font script="Sinh" typeface="Iskoola Pota"/>
+        <a:font script="Mong" typeface="Mongolian Baiti"/>
+        <a:font script="Viet" typeface="Arial"/>
+        <a:font script="Uigh" typeface="Microsoft Uighur"/>
+        <a:font script="Geor" typeface="Sylfaen"/>
+      </a:minorFont>
+    </a:fontScheme>
+    <a:fmtScheme name="Office">
+      <a:fillStyleLst>
+        <a:solidFill>
+          <a:schemeClr val="phClr"/>
+        </a:solidFill>
+        <a:gradFill rotWithShape="1">
+          <a:gsLst>
+            <a:gs pos="0">
+              <a:schemeClr val="phClr">
+                <a:tint val="50000"/>
+                <a:satMod val="300000"/>
+              </a:schemeClr>
+            </a:gs>
+            <a:gs pos="35000">
+              <a:schemeClr val="phClr">
+                <a:tint val="37000"/>
+                <a:satMod val="300000"/>
+              </a:schemeClr>
+            </a:gs>
+            <a:gs pos="100000">
+              <a:schemeClr val="phClr">
+                <a:tint val="15000"/>
+                <a:satMod val="350000"/>
+              </a:schemeClr>
+            </a:gs>
+          </a:gsLst>
+          <a:lin ang="16200000" scaled="1"/>
+        </a:gradFill>
+        <a:gradFill rotWithShape="1">
+          <a:gsLst>
+            <a:gs pos="0">
+              <a:schemeClr val="phClr">
+                <a:tint val="100000"/>
+                <a:shade val="100000"/>
+                <a:satMod val="130000"/>
+              </a:schemeClr>
+            </a:gs>
+            <a:gs pos="100000">
+              <a:schemeClr val="phClr">
+                <a:tint val="50000"/>
+                <a:shade val="100000"/>
+                <a:satMod val="350000"/>
+              </a:schemeClr>
+            </a:gs>
+          </a:gsLst>
+          <a:lin ang="16200000" scaled="0"/>
+        </a:gradFill>
+      </a:fillStyleLst>
+      <a:lnStyleLst>
+        <a:ln w="9525" cap="flat" cmpd="sng" algn="ctr">
+          <a:solidFill>
+            <a:schemeClr val="phClr">
+              <a:shade val="95000"/>
+              <a:satMod val="105000"/>
+            </a:schemeClr>
+          </a:solidFill>
+          <a:prstDash val="solid"/>
+        </a:ln>
+        <a:ln w="25400" cap="flat" cmpd="sng" algn="ctr">
+          <a:solidFill>
+            <a:schemeClr val="phClr"/>
+          </a:solidFill>
+          <a:prstDash val="solid"/>
+        </a:ln>
+        <a:ln w="38100" cap="flat" cmpd="sng" algn="ctr">
+          <a:solidFill>
+            <a:schemeClr val="phClr"/>
+          </a:solidFill>
+          <a:prstDash val="solid"/>
+        </a:ln>
+      </a:lnStyleLst>
+      <a:effectStyleLst>
+        <a:effectStyle>
+          <a:effectLst>
+            <a:outerShdw blurRad="40000" dist="20000" dir="5400000" rotWithShape="0">
+              <a:srgbClr val="000000">
+                <a:alpha val="38000"/>
+              </a:srgbClr>
+            </a:outerShdw>
+          </a:effectLst>
+        </a:effectStyle>
+        <a:effectStyle>
+          <a:effectLst>
+            <a:outerShdw blurRad="40000" dist="23000" dir="5400000" rotWithShape="0">
+              <a:srgbClr val="000000">
+                <a:alpha val="35000"/>
+              </a:srgbClr>
+            </a:outerShdw>
+          </a:effectLst>
+        </a:effectStyle>
+        <a:effectStyle>
+          <a:effectLst>
+            <a:outerShdw blurRad="40000" dist="23000" dir="5400000" rotWithShape="0">
+              <a:srgbClr val="000000">
+                <a:alpha val="35000"/>
+              </a:srgbClr>
+            </a:outerShdw>
+          </a:effectLst>
+          <a:scene3d>
+            <a:camera prst="orthographicFront">
+              <a:rot lat="0" lon="0" rev="0"/>
+            </a:camera>
+            <a:lightRig rig="threePt" dir="t">
+              <a:rot lat="0" lon="0" rev="1200000"/>
+            </a:lightRig>
+          </a:scene3d>
+          <a:sp3d>
+            <a:bevelT w="63500" h="25400"/>
+          </a:sp3d>
+        </a:effectStyle>
+      </a:effectStyleLst>
+      <a:bgFillStyleLst>
+        <a:solidFill>
+          <a:schemeClr val="phClr"/>
+        </a:solidFill>
+        <a:gradFill rotWithShape="1">
+          <a:gsLst>
+            <a:gs pos="0">
+              <a:schemeClr val="phClr">
+                <a:tint val="40000"/>
+                <a:satMod val="350000"/>
+              </a:schemeClr>
+            </a:gs>
+            <a:gs pos="40000">
+              <a:schemeClr val="phClr">
+                <a:tint val="45000"/>
+                <a:shade val="99000"/>
+                <a:satMod val="350000"/>
+              </a:schemeClr>
+            </a:gs>
+            <a:gs pos="100000">
+              <a:schemeClr val="phClr">
+                <a:shade val="20000"/>
+                <a:satMod val="255000"/>
+              </a:schemeClr>
+            </a:gs>
+          </a:gsLst>
+          <a:path path="circle">
+            <a:fillToRect l="50000" t="-80000" r="50000" b="180000"/>
+          </a:path>
+        </a:gradFill>
+        <a:gradFill rotWithShape="1">
+          <a:gsLst>
+            <a:gs pos="0">
+              <a:schemeClr val="phClr">
+                <a:tint val="80000"/>
+                <a:satMod val="300000"/>
+              </a:schemeClr>
+            </a:gs>
+            <a:gs pos="100000">
+              <a:schemeClr val="phClr">
+                <a:shade val="30000"/>
+                <a:satMod val="200000"/>
+              </a:schemeClr>
+            </a:gs>
+          </a:gsLst>
+          <a:path path="circle">
+            <a:fillToRect l="50000" t="50000" r="50000" b="50000"/>
+          </a:path>
+        </a:gradFill>
+      </a:bgFillStyleLst>
+    </a:fmtScheme>
+  </a:themeElements>
+</a:theme>
+</file>
+
+<file path=ppt/theme/theme2.xml><?xml version="1.0" encoding="utf-8"?>
 <a:theme xmlns:a="http://schemas.openxmlformats.org/drawingml/2006/main" xmlns:r="http://schemas.openxmlformats.org/officeDocument/2006/relationships">
   <a:themeElements>
     <a:clrScheme name="Default">
@@ -14354,283 +14512,4 @@
     </a:fmtScheme>
   </a:themeElements>
 </a:theme>
-</file>
-
-<file path=ppt/theme/theme2.xml><?xml version="1.0" encoding="utf-8"?>
-<a:theme xmlns:a="http://schemas.openxmlformats.org/drawingml/2006/main" xmlns:r="http://schemas.openxmlformats.org/officeDocument/2006/relationships" name="Office Theme">
-  <a:themeElements>
-    <a:clrScheme name="Office">
-      <a:dk1>
-        <a:srgbClr val="000000"/>
-      </a:dk1>
-      <a:lt1>
-        <a:srgbClr val="FFFFFF"/>
-      </a:lt1>
-      <a:dk2>
-        <a:srgbClr val="1F497D"/>
-      </a:dk2>
-      <a:lt2>
-        <a:srgbClr val="EEECE1"/>
-      </a:lt2>
-      <a:accent1>
-        <a:srgbClr val="4F81BD"/>
-      </a:accent1>
-      <a:accent2>
-        <a:srgbClr val="C0504D"/>
-      </a:accent2>
-      <a:accent3>
-        <a:srgbClr val="9BBB59"/>
-      </a:accent3>
-      <a:accent4>
-        <a:srgbClr val="8064A2"/>
-      </a:accent4>
-      <a:accent5>
-        <a:srgbClr val="4BACC6"/>
-      </a:accent5>
-      <a:accent6>
-        <a:srgbClr val="F79646"/>
-      </a:accent6>
-      <a:hlink>
-        <a:srgbClr val="0000FF"/>
-      </a:hlink>
-      <a:folHlink>
-        <a:srgbClr val="800080"/>
-      </a:folHlink>
-    </a:clrScheme>
-    <a:fontScheme name="Office">
-      <a:majorFont>
-        <a:latin typeface="Arial"/>
-        <a:ea typeface=""/>
-        <a:cs typeface=""/>
-        <a:font script="Jpan" typeface="ＭＳ Ｐゴシック"/>
-        <a:font script="Hang" typeface="맑은 고딕"/>
-        <a:font script="Hans" typeface="宋体"/>
-        <a:font script="Hant" typeface="新細明體"/>
-        <a:font script="Arab" typeface="Times New Roman"/>
-        <a:font script="Hebr" typeface="Times New Roman"/>
-        <a:font script="Thai" typeface="Angsana New"/>
-        <a:font script="Ethi" typeface="Nyala"/>
-        <a:font script="Beng" typeface="Vrinda"/>
-        <a:font script="Gujr" typeface="Shruti"/>
-        <a:font script="Khmr" typeface="MoolBoran"/>
-        <a:font script="Knda" typeface="Tunga"/>
-        <a:font script="Guru" typeface="Raavi"/>
-        <a:font script="Cans" typeface="Euphemia"/>
-        <a:font script="Cher" typeface="Plantagenet Cherokee"/>
-        <a:font script="Yiii" typeface="Microsoft Yi Baiti"/>
-        <a:font script="Tibt" typeface="Microsoft Himalaya"/>
-        <a:font script="Thaa" typeface="MV Boli"/>
-        <a:font script="Deva" typeface="Mangal"/>
-        <a:font script="Telu" typeface="Gautami"/>
-        <a:font script="Taml" typeface="Latha"/>
-        <a:font script="Syrc" typeface="Estrangelo Edessa"/>
-        <a:font script="Orya" typeface="Kalinga"/>
-        <a:font script="Mlym" typeface="Kartika"/>
-        <a:font script="Laoo" typeface="DokChampa"/>
-        <a:font script="Sinh" typeface="Iskoola Pota"/>
-        <a:font script="Mong" typeface="Mongolian Baiti"/>
-        <a:font script="Viet" typeface="Times New Roman"/>
-        <a:font script="Uigh" typeface="Microsoft Uighur"/>
-        <a:font script="Geor" typeface="Sylfaen"/>
-      </a:majorFont>
-      <a:minorFont>
-        <a:latin typeface="Arial"/>
-        <a:ea typeface=""/>
-        <a:cs typeface=""/>
-        <a:font script="Jpan" typeface="ＭＳ Ｐゴシック"/>
-        <a:font script="Hang" typeface="맑은 고딕"/>
-        <a:font script="Hans" typeface="宋体"/>
-        <a:font script="Hant" typeface="新細明體"/>
-        <a:font script="Arab" typeface="Arial"/>
-        <a:font script="Hebr" typeface="Arial"/>
-        <a:font script="Thai" typeface="Cordia New"/>
-        <a:font script="Ethi" typeface="Nyala"/>
-        <a:font script="Beng" typeface="Vrinda"/>
-        <a:font script="Gujr" typeface="Shruti"/>
-        <a:font script="Khmr" typeface="DaunPenh"/>
-        <a:font script="Knda" typeface="Tunga"/>
-        <a:font script="Guru" typeface="Raavi"/>
-        <a:font script="Cans" typeface="Euphemia"/>
-        <a:font script="Cher" typeface="Plantagenet Cherokee"/>
-        <a:font script="Yiii" typeface="Microsoft Yi Baiti"/>
-        <a:font script="Tibt" typeface="Microsoft Himalaya"/>
-        <a:font script="Thaa" typeface="MV Boli"/>
-        <a:font script="Deva" typeface="Mangal"/>
-        <a:font script="Telu" typeface="Gautami"/>
-        <a:font script="Taml" typeface="Latha"/>
-        <a:font script="Syrc" typeface="Estrangelo Edessa"/>
-        <a:font script="Orya" typeface="Kalinga"/>
-        <a:font script="Mlym" typeface="Kartika"/>
-        <a:font script="Laoo" typeface="DokChampa"/>
-        <a:font script="Sinh" typeface="Iskoola Pota"/>
-        <a:font script="Mong" typeface="Mongolian Baiti"/>
-        <a:font script="Viet" typeface="Arial"/>
-        <a:font script="Uigh" typeface="Microsoft Uighur"/>
-        <a:font script="Geor" typeface="Sylfaen"/>
-      </a:minorFont>
-    </a:fontScheme>
-    <a:fmtScheme name="Office">
-      <a:fillStyleLst>
-        <a:solidFill>
-          <a:schemeClr val="phClr"/>
-        </a:solidFill>
-        <a:gradFill rotWithShape="1">
-          <a:gsLst>
-            <a:gs pos="0">
-              <a:schemeClr val="phClr">
-                <a:tint val="50000"/>
-                <a:satMod val="300000"/>
-              </a:schemeClr>
-            </a:gs>
-            <a:gs pos="35000">
-              <a:schemeClr val="phClr">
-                <a:tint val="37000"/>
-                <a:satMod val="300000"/>
-              </a:schemeClr>
-            </a:gs>
-            <a:gs pos="100000">
-              <a:schemeClr val="phClr">
-                <a:tint val="15000"/>
-                <a:satMod val="350000"/>
-              </a:schemeClr>
-            </a:gs>
-          </a:gsLst>
-          <a:lin ang="16200000" scaled="1"/>
-        </a:gradFill>
-        <a:gradFill rotWithShape="1">
-          <a:gsLst>
-            <a:gs pos="0">
-              <a:schemeClr val="phClr">
-                <a:tint val="100000"/>
-                <a:shade val="100000"/>
-                <a:satMod val="130000"/>
-              </a:schemeClr>
-            </a:gs>
-            <a:gs pos="100000">
-              <a:schemeClr val="phClr">
-                <a:tint val="50000"/>
-                <a:shade val="100000"/>
-                <a:satMod val="350000"/>
-              </a:schemeClr>
-            </a:gs>
-          </a:gsLst>
-          <a:lin ang="16200000" scaled="0"/>
-        </a:gradFill>
-      </a:fillStyleLst>
-      <a:lnStyleLst>
-        <a:ln w="9525" cap="flat" cmpd="sng" algn="ctr">
-          <a:solidFill>
-            <a:schemeClr val="phClr">
-              <a:shade val="95000"/>
-              <a:satMod val="105000"/>
-            </a:schemeClr>
-          </a:solidFill>
-          <a:prstDash val="solid"/>
-        </a:ln>
-        <a:ln w="25400" cap="flat" cmpd="sng" algn="ctr">
-          <a:solidFill>
-            <a:schemeClr val="phClr"/>
-          </a:solidFill>
-          <a:prstDash val="solid"/>
-        </a:ln>
-        <a:ln w="38100" cap="flat" cmpd="sng" algn="ctr">
-          <a:solidFill>
-            <a:schemeClr val="phClr"/>
-          </a:solidFill>
-          <a:prstDash val="solid"/>
-        </a:ln>
-      </a:lnStyleLst>
-      <a:effectStyleLst>
-        <a:effectStyle>
-          <a:effectLst>
-            <a:outerShdw blurRad="40000" dist="20000" dir="5400000" rotWithShape="0">
-              <a:srgbClr val="000000">
-                <a:alpha val="38000"/>
-              </a:srgbClr>
-            </a:outerShdw>
-          </a:effectLst>
-        </a:effectStyle>
-        <a:effectStyle>
-          <a:effectLst>
-            <a:outerShdw blurRad="40000" dist="23000" dir="5400000" rotWithShape="0">
-              <a:srgbClr val="000000">
-                <a:alpha val="35000"/>
-              </a:srgbClr>
-            </a:outerShdw>
-          </a:effectLst>
-        </a:effectStyle>
-        <a:effectStyle>
-          <a:effectLst>
-            <a:outerShdw blurRad="40000" dist="23000" dir="5400000" rotWithShape="0">
-              <a:srgbClr val="000000">
-                <a:alpha val="35000"/>
-              </a:srgbClr>
-            </a:outerShdw>
-          </a:effectLst>
-          <a:scene3d>
-            <a:camera prst="orthographicFront">
-              <a:rot lat="0" lon="0" rev="0"/>
-            </a:camera>
-            <a:lightRig rig="threePt" dir="t">
-              <a:rot lat="0" lon="0" rev="1200000"/>
-            </a:lightRig>
-          </a:scene3d>
-          <a:sp3d>
-            <a:bevelT w="63500" h="25400"/>
-          </a:sp3d>
-        </a:effectStyle>
-      </a:effectStyleLst>
-      <a:bgFillStyleLst>
-        <a:solidFill>
-          <a:schemeClr val="phClr"/>
-        </a:solidFill>
-        <a:gradFill rotWithShape="1">
-          <a:gsLst>
-            <a:gs pos="0">
-              <a:schemeClr val="phClr">
-                <a:tint val="40000"/>
-                <a:satMod val="350000"/>
-              </a:schemeClr>
-            </a:gs>
-            <a:gs pos="40000">
-              <a:schemeClr val="phClr">
-                <a:tint val="45000"/>
-                <a:shade val="99000"/>
-                <a:satMod val="350000"/>
-              </a:schemeClr>
-            </a:gs>
-            <a:gs pos="100000">
-              <a:schemeClr val="phClr">
-                <a:shade val="20000"/>
-                <a:satMod val="255000"/>
-              </a:schemeClr>
-            </a:gs>
-          </a:gsLst>
-          <a:path path="circle">
-            <a:fillToRect l="50000" t="-80000" r="50000" b="180000"/>
-          </a:path>
-        </a:gradFill>
-        <a:gradFill rotWithShape="1">
-          <a:gsLst>
-            <a:gs pos="0">
-              <a:schemeClr val="phClr">
-                <a:tint val="80000"/>
-                <a:satMod val="300000"/>
-              </a:schemeClr>
-            </a:gs>
-            <a:gs pos="100000">
-              <a:schemeClr val="phClr">
-                <a:shade val="30000"/>
-                <a:satMod val="200000"/>
-              </a:schemeClr>
-            </a:gs>
-          </a:gsLst>
-          <a:path path="circle">
-            <a:fillToRect l="50000" t="50000" r="50000" b="50000"/>
-          </a:path>
-        </a:gradFill>
-      </a:bgFillStyleLst>
-    </a:fmtScheme>
-  </a:themeElements>
-</a:theme>
 </file>
</xml_diff>

<commit_message>
US482-TASK496: Created Museum Generation and System Architecture Sections and added a cool image.
</commit_message>
<xml_diff>
--- a/Team 32 Innovation Showcase Poster.pptx
+++ b/Team 32 Innovation Showcase Poster.pptx
@@ -1,6 +1,6 @@
 
 <file path=ppt/presentation.xml><?xml version="1.0" encoding="utf-8"?>
-<p:presentation xmlns:a="http://schemas.openxmlformats.org/drawingml/2006/main" xmlns:r="http://schemas.openxmlformats.org/officeDocument/2006/relationships" xmlns:mc="http://schemas.openxmlformats.org/markup-compatibility/2006" xmlns:mv="urn:schemas-microsoft-com:mac:vml" xmlns:p="http://schemas.openxmlformats.org/presentationml/2006/main" xmlns:c="http://schemas.openxmlformats.org/drawingml/2006/chart" xmlns:dgm="http://schemas.openxmlformats.org/drawingml/2006/diagram" xmlns:o="urn:schemas-microsoft-com:office:office" xmlns:v="urn:schemas-microsoft-com:vml" xmlns:pvml="urn:schemas-microsoft-com:office:powerpoint" xmlns:com="http://schemas.openxmlformats.org/drawingml/2006/compatibility" xmlns:p14="http://schemas.microsoft.com/office/powerpoint/2010/main" xmlns:p15="http://schemas.microsoft.com/office/powerpoint/2012/main" xmlns:ahyp="http://schemas.microsoft.com/office/drawing/2018/hyperlinkcolor" autoCompressPictures="0" strictFirstAndLastChars="0" saveSubsetFonts="1">
+<p:presentation xmlns:a="http://schemas.openxmlformats.org/drawingml/2006/main" xmlns:r="http://schemas.openxmlformats.org/officeDocument/2006/relationships" xmlns:mc="http://schemas.openxmlformats.org/markup-compatibility/2006" xmlns:mv="urn:schemas-microsoft-com:mac:vml" xmlns:p="http://schemas.openxmlformats.org/presentationml/2006/main" xmlns:c="http://schemas.openxmlformats.org/drawingml/2006/chart" xmlns:dgm="http://schemas.openxmlformats.org/drawingml/2006/diagram" xmlns:o="urn:schemas-microsoft-com:office:office" xmlns:v="urn:schemas-microsoft-com:vml" xmlns:pvml="urn:schemas-microsoft-com:office:powerpoint" xmlns:com="http://schemas.openxmlformats.org/drawingml/2006/compatibility" xmlns:p14="http://schemas.microsoft.com/office/powerpoint/2010/main" xmlns:p15="http://schemas.microsoft.com/office/powerpoint/2012/main" xmlns:ahyp="http://schemas.microsoft.com/office/drawing/2018/hyperlinkcolor" autoCompressPictures="0" embedTrueTypeFonts="1" strictFirstAndLastChars="0" saveSubsetFonts="1">
   <p:sldMasterIdLst>
     <p:sldMasterId id="2147483648" r:id="rId4"/>
   </p:sldMasterIdLst>
@@ -12,6 +12,22 @@
   </p:sldIdLst>
   <p:sldSz cy="21031200" cx="32004000"/>
   <p:notesSz cx="6858000" cy="9144000"/>
+  <p:embeddedFontLst>
+    <p:embeddedFont>
+      <p:font typeface="Helvetica Neue"/>
+      <p:regular r:id="rId7"/>
+      <p:bold r:id="rId8"/>
+      <p:italic r:id="rId9"/>
+      <p:boldItalic r:id="rId10"/>
+    </p:embeddedFont>
+    <p:embeddedFont>
+      <p:font typeface="Helvetica Neue Light"/>
+      <p:regular r:id="rId11"/>
+      <p:bold r:id="rId12"/>
+      <p:italic r:id="rId13"/>
+      <p:boldItalic r:id="rId14"/>
+    </p:embeddedFont>
+  </p:embeddedFontLst>
   <p:defaultTextStyle>
     <a:defPPr lvl="0" marR="0" rtl="0" algn="l">
       <a:lnSpc>
@@ -257,7 +273,7 @@
       </p15:sldGuideLst>
     </p:ext>
     <p:ext uri="GoogleSlidesCustomDataVersion2">
-      <go:slidesCustomData xmlns:go="http://customooxmlschemas.google.com/" r:id="rId7" roundtripDataSignature="AMtx7mgqw4verhR8mXoJd3+pxlrBKF7zFw=="/>
+      <go:slidesCustomData xmlns:go="http://customooxmlschemas.google.com/" r:id="rId15" roundtripDataSignature="AMtx7mh1F+bSPhaCu8SQkugYOBbTGXamCA=="/>
     </p:ext>
   </p:extLst>
 </p:presentation>
@@ -13174,7 +13190,7 @@
         </p:nvSpPr>
         <p:spPr>
           <a:xfrm>
-            <a:off x="381000" y="381000"/>
+            <a:off x="381000" y="235275"/>
             <a:ext cx="31242000" cy="20269200"/>
           </a:xfrm>
           <a:prstGeom prst="rect">
@@ -13214,19 +13230,23 @@
               <a:spcAft>
                 <a:spcPts val="0"/>
               </a:spcAft>
+              <a:buClr>
+                <a:srgbClr val="000000"/>
+              </a:buClr>
+              <a:buFont typeface="Arial"/>
               <a:buNone/>
             </a:pPr>
             <a:r>
               <a:t/>
             </a:r>
-            <a:endParaRPr b="0" i="0" sz="6000" u="none">
+            <a:endParaRPr i="0" sz="6000" u="none">
               <a:solidFill>
                 <a:schemeClr val="dk1"/>
               </a:solidFill>
-              <a:latin typeface="Arial"/>
-              <a:ea typeface="Arial"/>
-              <a:cs typeface="Arial"/>
-              <a:sym typeface="Arial"/>
+              <a:latin typeface="Helvetica Neue Light"/>
+              <a:ea typeface="Helvetica Neue Light"/>
+              <a:cs typeface="Helvetica Neue Light"/>
+              <a:sym typeface="Helvetica Neue Light"/>
             </a:endParaRPr>
           </a:p>
         </p:txBody>
@@ -13246,7 +13266,7 @@
         </p:blipFill>
         <p:spPr>
           <a:xfrm>
-            <a:off x="22698550" y="381000"/>
+            <a:off x="22698550" y="333100"/>
             <a:ext cx="8924450" cy="2956375"/>
           </a:xfrm>
           <a:prstGeom prst="rect">
@@ -13274,7 +13294,7 @@
         </p:blipFill>
         <p:spPr>
           <a:xfrm>
-            <a:off x="381000" y="381000"/>
+            <a:off x="381000" y="333100"/>
             <a:ext cx="2956375" cy="2956375"/>
           </a:xfrm>
           <a:prstGeom prst="rect">
@@ -13294,7 +13314,7 @@
         </p:nvSpPr>
         <p:spPr>
           <a:xfrm>
-            <a:off x="4044325" y="381000"/>
+            <a:off x="4044325" y="333100"/>
             <a:ext cx="19071900" cy="3263100"/>
           </a:xfrm>
           <a:prstGeom prst="rect">
@@ -13325,10 +13345,10 @@
                 <a:solidFill>
                   <a:schemeClr val="dk1"/>
                 </a:solidFill>
-                <a:latin typeface="Calibri"/>
-                <a:ea typeface="Calibri"/>
-                <a:cs typeface="Calibri"/>
-                <a:sym typeface="Calibri"/>
+                <a:latin typeface="Helvetica Neue Light"/>
+                <a:ea typeface="Helvetica Neue Light"/>
+                <a:cs typeface="Helvetica Neue Light"/>
+                <a:sym typeface="Helvetica Neue Light"/>
               </a:rPr>
               <a:t>Virtual Reality Psyche Inspired Art and Artists Showcase</a:t>
             </a:r>
@@ -13336,10 +13356,10 @@
               <a:solidFill>
                 <a:schemeClr val="dk1"/>
               </a:solidFill>
-              <a:latin typeface="Calibri"/>
-              <a:ea typeface="Calibri"/>
-              <a:cs typeface="Calibri"/>
-              <a:sym typeface="Calibri"/>
+              <a:latin typeface="Helvetica Neue Light"/>
+              <a:ea typeface="Helvetica Neue Light"/>
+              <a:cs typeface="Helvetica Neue Light"/>
+              <a:sym typeface="Helvetica Neue Light"/>
             </a:endParaRPr>
           </a:p>
         </p:txBody>
@@ -13352,8 +13372,8 @@
         </p:nvSpPr>
         <p:spPr>
           <a:xfrm>
-            <a:off x="11288250" y="4055850"/>
-            <a:ext cx="9427500" cy="6095400"/>
+            <a:off x="11288250" y="4007950"/>
+            <a:ext cx="9427500" cy="5849100"/>
           </a:xfrm>
           <a:prstGeom prst="rect">
             <a:avLst/>
@@ -13361,8 +13381,14 @@
           <a:solidFill>
             <a:srgbClr val="F9A000"/>
           </a:solidFill>
-          <a:ln>
-            <a:noFill/>
+          <a:ln cap="flat" cmpd="sng" w="76200">
+            <a:solidFill>
+              <a:srgbClr val="592651"/>
+            </a:solidFill>
+            <a:prstDash val="solid"/>
+            <a:round/>
+            <a:headEnd len="sm" w="sm" type="none"/>
+            <a:tailEnd len="sm" w="sm" type="none"/>
           </a:ln>
         </p:spPr>
         <p:txBody>
@@ -13381,25 +13407,25 @@
               <a:buNone/>
             </a:pPr>
             <a:r>
-              <a:rPr lang="en-US" sz="4800">
+              <a:rPr lang="en-US" sz="4600">
                 <a:solidFill>
                   <a:schemeClr val="dk1"/>
                 </a:solidFill>
-                <a:latin typeface="Calibri"/>
-                <a:ea typeface="Calibri"/>
-                <a:cs typeface="Calibri"/>
-                <a:sym typeface="Calibri"/>
+                <a:latin typeface="Helvetica Neue Light"/>
+                <a:ea typeface="Helvetica Neue Light"/>
+                <a:cs typeface="Helvetica Neue Light"/>
+                <a:sym typeface="Helvetica Neue Light"/>
               </a:rPr>
               <a:t>Web Scraper</a:t>
             </a:r>
-            <a:endParaRPr sz="4800">
+            <a:endParaRPr sz="4600">
               <a:solidFill>
                 <a:schemeClr val="dk1"/>
               </a:solidFill>
-              <a:latin typeface="Calibri"/>
-              <a:ea typeface="Calibri"/>
-              <a:cs typeface="Calibri"/>
-              <a:sym typeface="Calibri"/>
+              <a:latin typeface="Helvetica Neue Light"/>
+              <a:ea typeface="Helvetica Neue Light"/>
+              <a:cs typeface="Helvetica Neue Light"/>
+              <a:sym typeface="Helvetica Neue Light"/>
             </a:endParaRPr>
           </a:p>
           <a:p>
@@ -13413,49 +13439,25 @@
               <a:buNone/>
             </a:pPr>
             <a:r>
-              <a:rPr lang="en-US" sz="2400">
+              <a:rPr lang="en-US" sz="2300">
                 <a:solidFill>
                   <a:schemeClr val="dk1"/>
                 </a:solidFill>
-                <a:latin typeface="Calibri"/>
-                <a:ea typeface="Calibri"/>
-                <a:cs typeface="Calibri"/>
-                <a:sym typeface="Calibri"/>
+                <a:latin typeface="Helvetica Neue Light"/>
+                <a:ea typeface="Helvetica Neue Light"/>
+                <a:cs typeface="Helvetica Neue Light"/>
+                <a:sym typeface="Helvetica Neue Light"/>
               </a:rPr>
-              <a:t>The </a:t>
+              <a:t>The media files for all Psyche Inspired projects are hosted on the online Psyche Artwork Gallery. Each project file must be downloaded and stored locally in order to appear in the museum. Our team created a spreadsheet that stores the information about each project (title, artist, medium, etc.) as well as the link to the project’s page within Psyche's online gallery. Our software analyzes the spreadsheet and uses our web scraper, which visits the webpage and downloads all media attached to a project, whether that be an image, a YouTube video, a gif, or something else. It then stores these media files along with their associated project information in a local SQLite database. This database creator/updater has been containerized using Docker for ease of use. Once this database has been populated, the Unity VR program is able to read from the database and populate art frames on the museum walls with the project's media, whatever filetype that might be.</a:t>
             </a:r>
-            <a:r>
-              <a:rPr lang="en-US" sz="2400">
-                <a:solidFill>
-                  <a:schemeClr val="dk1"/>
-                </a:solidFill>
-                <a:latin typeface="Calibri"/>
-                <a:ea typeface="Calibri"/>
-                <a:cs typeface="Calibri"/>
-                <a:sym typeface="Calibri"/>
-              </a:rPr>
-              <a:t>media</a:t>
-            </a:r>
-            <a:r>
-              <a:rPr lang="en-US" sz="2400">
-                <a:solidFill>
-                  <a:schemeClr val="dk1"/>
-                </a:solidFill>
-                <a:latin typeface="Calibri"/>
-                <a:ea typeface="Calibri"/>
-                <a:cs typeface="Calibri"/>
-                <a:sym typeface="Calibri"/>
-              </a:rPr>
-              <a:t> files for the Psyche Inspired projects are hosted on a NASA website.  All of these files must be downloaded and stored locally in order to appear in the museum.  Our team created a CSV table that storing the information about each project (title, artist, medium, etc.) as well as the link to the project’s page on the NASA website.  The webscraper, which is set up in Docker for user ease, visits the webpage and downloads the project media files, whether that be an image, a YouTube video, or a gif.  It then stores these media files along with their associated project information in a local database.  When this database has been populated, the Unity VR program is able to read from the database and populate art frames on the museum walls with the images.  A small plaque to the side of the frame holds the basic art and artist information.  Clicking a button next to the plaque expands it to show the full artist’s description of the work.</a:t>
-            </a:r>
-            <a:endParaRPr sz="2400">
+            <a:endParaRPr sz="2300">
               <a:solidFill>
                 <a:schemeClr val="dk1"/>
               </a:solidFill>
-              <a:latin typeface="Calibri"/>
-              <a:ea typeface="Calibri"/>
-              <a:cs typeface="Calibri"/>
-              <a:sym typeface="Calibri"/>
+              <a:latin typeface="Helvetica Neue Light"/>
+              <a:ea typeface="Helvetica Neue Light"/>
+              <a:cs typeface="Helvetica Neue Light"/>
+              <a:sym typeface="Helvetica Neue Light"/>
             </a:endParaRPr>
           </a:p>
         </p:txBody>
@@ -13468,8 +13470,8 @@
         </p:nvSpPr>
         <p:spPr>
           <a:xfrm>
-            <a:off x="899050" y="11246825"/>
-            <a:ext cx="9427500" cy="3509400"/>
+            <a:off x="957550" y="10421975"/>
+            <a:ext cx="9427500" cy="4433100"/>
           </a:xfrm>
           <a:prstGeom prst="rect">
             <a:avLst/>
@@ -13477,8 +13479,14 @@
           <a:solidFill>
             <a:srgbClr val="F9A000"/>
           </a:solidFill>
-          <a:ln>
-            <a:noFill/>
+          <a:ln cap="flat" cmpd="sng" w="76200">
+            <a:solidFill>
+              <a:srgbClr val="592651"/>
+            </a:solidFill>
+            <a:prstDash val="solid"/>
+            <a:round/>
+            <a:headEnd len="sm" w="sm" type="none"/>
+            <a:tailEnd len="sm" w="sm" type="none"/>
           </a:ln>
         </p:spPr>
         <p:txBody>
@@ -13497,25 +13505,25 @@
               <a:buNone/>
             </a:pPr>
             <a:r>
-              <a:rPr lang="en-US" sz="4800">
+              <a:rPr lang="en-US" sz="4600">
                 <a:solidFill>
                   <a:schemeClr val="dk1"/>
                 </a:solidFill>
-                <a:latin typeface="Calibri"/>
-                <a:ea typeface="Calibri"/>
-                <a:cs typeface="Calibri"/>
-                <a:sym typeface="Calibri"/>
+                <a:latin typeface="Helvetica Neue Light"/>
+                <a:ea typeface="Helvetica Neue Light"/>
+                <a:cs typeface="Helvetica Neue Light"/>
+                <a:sym typeface="Helvetica Neue Light"/>
               </a:rPr>
               <a:t>System Architecture</a:t>
             </a:r>
-            <a:endParaRPr sz="4800">
+            <a:endParaRPr sz="4600">
               <a:solidFill>
                 <a:schemeClr val="dk1"/>
               </a:solidFill>
-              <a:latin typeface="Calibri"/>
-              <a:ea typeface="Calibri"/>
-              <a:cs typeface="Calibri"/>
-              <a:sym typeface="Calibri"/>
+              <a:latin typeface="Helvetica Neue Light"/>
+              <a:ea typeface="Helvetica Neue Light"/>
+              <a:cs typeface="Helvetica Neue Light"/>
+              <a:sym typeface="Helvetica Neue Light"/>
             </a:endParaRPr>
           </a:p>
           <a:p>
@@ -13529,25 +13537,121 @@
               <a:buNone/>
             </a:pPr>
             <a:r>
-              <a:rPr lang="en-US" sz="2400">
+              <a:rPr lang="en-US" sz="2300">
                 <a:solidFill>
                   <a:schemeClr val="dk1"/>
                 </a:solidFill>
-                <a:latin typeface="Calibri"/>
-                <a:ea typeface="Calibri"/>
-                <a:cs typeface="Calibri"/>
-                <a:sym typeface="Calibri"/>
+                <a:latin typeface="Helvetica Neue Light"/>
+                <a:ea typeface="Helvetica Neue Light"/>
+                <a:cs typeface="Helvetica Neue Light"/>
+                <a:sym typeface="Helvetica Neue Light"/>
               </a:rPr>
-              <a:t>Lorem ipsum dolor sit amet, consectetur adipiscing elit, sed do eiusmod tempor incididunt ut labore et dolore magna aliqua. Ut enim ad minim veniam, quis nostrud exercitation ullamco laboris nisi ut aliquip ex ea commodo consequat. Duis aute irure dolor in reprehenderit in voluptate velit esse cillum dolore eu fugiat nulla pariatur. Excepteur sint occaecat cupidatat non proident, sunt in culpa qui officia deserunt mollit anim id est laborum.</a:t>
+              <a:t>Internally, the system is divided up into three main systems that all talk to each other. These are the </a:t>
             </a:r>
-            <a:endParaRPr sz="2400">
+            <a:r>
+              <a:rPr b="1" lang="en-US" sz="2300">
+                <a:solidFill>
+                  <a:schemeClr val="dk1"/>
+                </a:solidFill>
+                <a:latin typeface="Helvetica Neue"/>
+                <a:ea typeface="Helvetica Neue"/>
+                <a:cs typeface="Helvetica Neue"/>
+                <a:sym typeface="Helvetica Neue"/>
+              </a:rPr>
+              <a:t>Museum Layout Generator</a:t>
+            </a:r>
+            <a:r>
+              <a:rPr lang="en-US" sz="2300">
+                <a:solidFill>
+                  <a:schemeClr val="dk1"/>
+                </a:solidFill>
+                <a:latin typeface="Helvetica Neue Light"/>
+                <a:ea typeface="Helvetica Neue Light"/>
+                <a:cs typeface="Helvetica Neue Light"/>
+                <a:sym typeface="Helvetica Neue Light"/>
+              </a:rPr>
+              <a:t>, the </a:t>
+            </a:r>
+            <a:r>
+              <a:rPr b="1" lang="en-US" sz="2300">
+                <a:solidFill>
+                  <a:schemeClr val="dk1"/>
+                </a:solidFill>
+                <a:latin typeface="Helvetica Neue"/>
+                <a:ea typeface="Helvetica Neue"/>
+                <a:cs typeface="Helvetica Neue"/>
+                <a:sym typeface="Helvetica Neue"/>
+              </a:rPr>
+              <a:t>Artwork Displays</a:t>
+            </a:r>
+            <a:r>
+              <a:rPr lang="en-US" sz="2300">
+                <a:solidFill>
+                  <a:schemeClr val="dk1"/>
+                </a:solidFill>
+                <a:latin typeface="Helvetica Neue Light"/>
+                <a:ea typeface="Helvetica Neue Light"/>
+                <a:cs typeface="Helvetica Neue Light"/>
+                <a:sym typeface="Helvetica Neue Light"/>
+              </a:rPr>
+              <a:t>, and the </a:t>
+            </a:r>
+            <a:r>
+              <a:rPr b="1" lang="en-US" sz="2300">
+                <a:solidFill>
+                  <a:schemeClr val="dk1"/>
+                </a:solidFill>
+                <a:latin typeface="Helvetica Neue"/>
+                <a:ea typeface="Helvetica Neue"/>
+                <a:cs typeface="Helvetica Neue"/>
+                <a:sym typeface="Helvetica Neue"/>
+              </a:rPr>
+              <a:t>Database Middleware</a:t>
+            </a:r>
+            <a:r>
+              <a:rPr lang="en-US" sz="2300">
+                <a:solidFill>
+                  <a:schemeClr val="dk1"/>
+                </a:solidFill>
+                <a:latin typeface="Helvetica Neue Light"/>
+                <a:ea typeface="Helvetica Neue Light"/>
+                <a:cs typeface="Helvetica Neue Light"/>
+                <a:sym typeface="Helvetica Neue Light"/>
+              </a:rPr>
+              <a:t>. During normal operation, the system follows a pattern of first having the Museum Layout Generator create a layout, which then sends the populate signal to the Artwork Displays, which individually request artwork from the Database Middleware, which reads from the database generated by the </a:t>
+            </a:r>
+            <a:r>
+              <a:rPr b="1" lang="en-US" sz="2300">
+                <a:solidFill>
+                  <a:schemeClr val="dk1"/>
+                </a:solidFill>
+                <a:latin typeface="Helvetica Neue"/>
+                <a:ea typeface="Helvetica Neue"/>
+                <a:cs typeface="Helvetica Neue"/>
+                <a:sym typeface="Helvetica Neue"/>
+              </a:rPr>
+              <a:t>Web Scraper</a:t>
+            </a:r>
+            <a:r>
+              <a:rPr lang="en-US" sz="2300">
+                <a:solidFill>
+                  <a:schemeClr val="dk1"/>
+                </a:solidFill>
+                <a:latin typeface="Helvetica Neue Light"/>
+                <a:ea typeface="Helvetica Neue Light"/>
+                <a:cs typeface="Helvetica Neue Light"/>
+                <a:sym typeface="Helvetica Neue Light"/>
+              </a:rPr>
+              <a:t>. Each of these major systems rely on each other to fully build out and populate a new museum, but are still fairly independent in their function.</a:t>
+            </a:r>
+            <a:endParaRPr sz="2300">
               <a:solidFill>
                 <a:schemeClr val="dk1"/>
               </a:solidFill>
-              <a:latin typeface="Calibri"/>
-              <a:ea typeface="Calibri"/>
-              <a:cs typeface="Calibri"/>
-              <a:sym typeface="Calibri"/>
+              <a:latin typeface="Helvetica Neue Light"/>
+              <a:ea typeface="Helvetica Neue Light"/>
+              <a:cs typeface="Helvetica Neue Light"/>
+              <a:sym typeface="Helvetica Neue Light"/>
             </a:endParaRPr>
           </a:p>
         </p:txBody>
@@ -13560,8 +13664,8 @@
         </p:nvSpPr>
         <p:spPr>
           <a:xfrm>
-            <a:off x="21618950" y="4055850"/>
-            <a:ext cx="9427500" cy="3509400"/>
+            <a:off x="21618950" y="4007950"/>
+            <a:ext cx="9427500" cy="3724800"/>
           </a:xfrm>
           <a:prstGeom prst="rect">
             <a:avLst/>
@@ -13569,8 +13673,14 @@
           <a:solidFill>
             <a:srgbClr val="F9A000"/>
           </a:solidFill>
-          <a:ln>
-            <a:noFill/>
+          <a:ln cap="flat" cmpd="sng" w="76200">
+            <a:solidFill>
+              <a:srgbClr val="592651"/>
+            </a:solidFill>
+            <a:prstDash val="solid"/>
+            <a:round/>
+            <a:headEnd len="sm" w="sm" type="none"/>
+            <a:tailEnd len="sm" w="sm" type="none"/>
           </a:ln>
         </p:spPr>
         <p:txBody>
@@ -13589,25 +13699,25 @@
               <a:buNone/>
             </a:pPr>
             <a:r>
-              <a:rPr lang="en-US" sz="4800">
+              <a:rPr lang="en-US" sz="4600">
                 <a:solidFill>
                   <a:schemeClr val="dk1"/>
                 </a:solidFill>
-                <a:latin typeface="Calibri"/>
-                <a:ea typeface="Calibri"/>
-                <a:cs typeface="Calibri"/>
-                <a:sym typeface="Calibri"/>
+                <a:latin typeface="Helvetica Neue Light"/>
+                <a:ea typeface="Helvetica Neue Light"/>
+                <a:cs typeface="Helvetica Neue Light"/>
+                <a:sym typeface="Helvetica Neue Light"/>
               </a:rPr>
               <a:t>Museum Layout Generation</a:t>
             </a:r>
-            <a:endParaRPr sz="4800">
+            <a:endParaRPr sz="4600">
               <a:solidFill>
                 <a:schemeClr val="dk1"/>
               </a:solidFill>
-              <a:latin typeface="Calibri"/>
-              <a:ea typeface="Calibri"/>
-              <a:cs typeface="Calibri"/>
-              <a:sym typeface="Calibri"/>
+              <a:latin typeface="Helvetica Neue Light"/>
+              <a:ea typeface="Helvetica Neue Light"/>
+              <a:cs typeface="Helvetica Neue Light"/>
+              <a:sym typeface="Helvetica Neue Light"/>
             </a:endParaRPr>
           </a:p>
           <a:p>
@@ -13621,25 +13731,49 @@
               <a:buNone/>
             </a:pPr>
             <a:r>
-              <a:rPr lang="en-US" sz="2400">
+              <a:rPr lang="en-US" sz="2300">
                 <a:solidFill>
                   <a:schemeClr val="dk1"/>
                 </a:solidFill>
-                <a:latin typeface="Calibri"/>
-                <a:ea typeface="Calibri"/>
-                <a:cs typeface="Calibri"/>
-                <a:sym typeface="Calibri"/>
+                <a:latin typeface="Helvetica Neue Light"/>
+                <a:ea typeface="Helvetica Neue Light"/>
+                <a:cs typeface="Helvetica Neue Light"/>
+                <a:sym typeface="Helvetica Neue Light"/>
               </a:rPr>
-              <a:t>Lorem ipsum dolor sit amet, consectetur adipiscing elit, sed do eiusmod tempor incididunt ut labore et dolore magna aliqua. Ut enim ad minim veniam, quis nostrud exercitation ullamco laboris nisi ut aliquip ex ea commodo consequat. Duis aute irure dolor in reprehenderit in voluptate velit esse cillum dolore eu fugiat nulla pariatur. Excepteur sint occaecat cupidatat non proident, sunt in culpa qui officia deserunt mollit anim id est laborum.</a:t>
+              <a:t>Every time a new user enters the museum, an entirely fresh museum layout is generated, given some number of artworks to display. The algorithm snakes through a grid and determines where rooms will be and to which rooms they will connect. Then, spread out along the walls, art displays (see </a:t>
             </a:r>
-            <a:endParaRPr sz="2400">
+            <a:r>
+              <a:rPr b="1" lang="en-US" sz="2300">
+                <a:solidFill>
+                  <a:schemeClr val="dk1"/>
+                </a:solidFill>
+                <a:latin typeface="Helvetica Neue"/>
+                <a:ea typeface="Helvetica Neue"/>
+                <a:cs typeface="Helvetica Neue"/>
+                <a:sym typeface="Helvetica Neue"/>
+              </a:rPr>
+              <a:t>Artwork Display</a:t>
+            </a:r>
+            <a:r>
+              <a:rPr lang="en-US" sz="2300">
+                <a:solidFill>
+                  <a:schemeClr val="dk1"/>
+                </a:solidFill>
+                <a:latin typeface="Helvetica Neue Light"/>
+                <a:ea typeface="Helvetica Neue Light"/>
+                <a:cs typeface="Helvetica Neue Light"/>
+                <a:sym typeface="Helvetica Neue Light"/>
+              </a:rPr>
+              <a:t>) are populated with random art from our database. As a final step, to give the museum some flair, we add in fun decorations that our team has produced. Once all these steps are completed, the user is free to explore their uniquely generated museum!</a:t>
+            </a:r>
+            <a:endParaRPr sz="2300">
               <a:solidFill>
                 <a:schemeClr val="dk1"/>
               </a:solidFill>
-              <a:latin typeface="Calibri"/>
-              <a:ea typeface="Calibri"/>
-              <a:cs typeface="Calibri"/>
-              <a:sym typeface="Calibri"/>
+              <a:latin typeface="Helvetica Neue Light"/>
+              <a:ea typeface="Helvetica Neue Light"/>
+              <a:cs typeface="Helvetica Neue Light"/>
+              <a:sym typeface="Helvetica Neue Light"/>
             </a:endParaRPr>
           </a:p>
         </p:txBody>
@@ -13652,7 +13786,7 @@
         </p:nvSpPr>
         <p:spPr>
           <a:xfrm>
-            <a:off x="840550" y="19201150"/>
+            <a:off x="840550" y="19153250"/>
             <a:ext cx="9544500" cy="1200600"/>
           </a:xfrm>
           <a:prstGeom prst="rect">
@@ -13661,8 +13795,14 @@
           <a:solidFill>
             <a:srgbClr val="F9A000"/>
           </a:solidFill>
-          <a:ln>
-            <a:noFill/>
+          <a:ln cap="flat" cmpd="sng" w="76200">
+            <a:solidFill>
+              <a:srgbClr val="592651"/>
+            </a:solidFill>
+            <a:prstDash val="solid"/>
+            <a:round/>
+            <a:headEnd len="sm" w="sm" type="none"/>
+            <a:tailEnd len="sm" w="sm" type="none"/>
           </a:ln>
         </p:spPr>
         <p:txBody>
@@ -13750,8 +13890,8 @@
         </p:nvSpPr>
         <p:spPr>
           <a:xfrm>
-            <a:off x="957550" y="4059750"/>
-            <a:ext cx="9427500" cy="6464700"/>
+            <a:off x="957550" y="4011850"/>
+            <a:ext cx="9427500" cy="6203100"/>
           </a:xfrm>
           <a:prstGeom prst="rect">
             <a:avLst/>
@@ -13759,8 +13899,14 @@
           <a:solidFill>
             <a:srgbClr val="F9A000"/>
           </a:solidFill>
-          <a:ln>
-            <a:noFill/>
+          <a:ln cap="flat" cmpd="sng" w="76200">
+            <a:solidFill>
+              <a:srgbClr val="592651"/>
+            </a:solidFill>
+            <a:prstDash val="solid"/>
+            <a:round/>
+            <a:headEnd len="sm" w="sm" type="none"/>
+            <a:tailEnd len="sm" w="sm" type="none"/>
           </a:ln>
         </p:spPr>
         <p:txBody>
@@ -13779,25 +13925,25 @@
               <a:buNone/>
             </a:pPr>
             <a:r>
-              <a:rPr lang="en-US" sz="4800">
+              <a:rPr lang="en-US" sz="4600">
                 <a:solidFill>
                   <a:schemeClr val="dk1"/>
                 </a:solidFill>
-                <a:latin typeface="Calibri"/>
-                <a:ea typeface="Calibri"/>
-                <a:cs typeface="Calibri"/>
-                <a:sym typeface="Calibri"/>
+                <a:latin typeface="Helvetica Neue Light"/>
+                <a:ea typeface="Helvetica Neue Light"/>
+                <a:cs typeface="Helvetica Neue Light"/>
+                <a:sym typeface="Helvetica Neue Light"/>
               </a:rPr>
               <a:t>Project Overview</a:t>
             </a:r>
-            <a:endParaRPr sz="4800">
+            <a:endParaRPr sz="4600">
               <a:solidFill>
                 <a:schemeClr val="dk1"/>
               </a:solidFill>
-              <a:latin typeface="Calibri"/>
-              <a:ea typeface="Calibri"/>
-              <a:cs typeface="Calibri"/>
-              <a:sym typeface="Calibri"/>
+              <a:latin typeface="Helvetica Neue Light"/>
+              <a:ea typeface="Helvetica Neue Light"/>
+              <a:cs typeface="Helvetica Neue Light"/>
+              <a:sym typeface="Helvetica Neue Light"/>
             </a:endParaRPr>
           </a:p>
           <a:p>
@@ -13811,25 +13957,25 @@
               <a:buNone/>
             </a:pPr>
             <a:r>
-              <a:rPr lang="en-US" sz="2400">
+              <a:rPr lang="en-US" sz="2300">
                 <a:solidFill>
                   <a:schemeClr val="dk1"/>
                 </a:solidFill>
-                <a:latin typeface="Calibri"/>
-                <a:ea typeface="Calibri"/>
-                <a:cs typeface="Calibri"/>
-                <a:sym typeface="Calibri"/>
+                <a:latin typeface="Helvetica Neue Light"/>
+                <a:ea typeface="Helvetica Neue Light"/>
+                <a:cs typeface="Helvetica Neue Light"/>
+                <a:sym typeface="Helvetica Neue Light"/>
               </a:rPr>
               <a:t>On October 13th, 2023, NASA launched a space probe destined for the Psyche asteroid.  This probe, also named Psyche, will orbit the asteroid to take measurements that could provide insights into the formation of Earth itself.  As part of Psyche Inspired, the mission’s public outreach program, classes of students from numerous universities over the years have created art projects in diverse media expressing what the Psyche mission means to them.</a:t>
             </a:r>
-            <a:endParaRPr sz="2400">
+            <a:endParaRPr sz="2300">
               <a:solidFill>
                 <a:schemeClr val="dk1"/>
               </a:solidFill>
-              <a:latin typeface="Calibri"/>
-              <a:ea typeface="Calibri"/>
-              <a:cs typeface="Calibri"/>
-              <a:sym typeface="Calibri"/>
+              <a:latin typeface="Helvetica Neue Light"/>
+              <a:ea typeface="Helvetica Neue Light"/>
+              <a:cs typeface="Helvetica Neue Light"/>
+              <a:sym typeface="Helvetica Neue Light"/>
             </a:endParaRPr>
           </a:p>
           <a:p>
@@ -13843,25 +13989,25 @@
               <a:buNone/>
             </a:pPr>
             <a:r>
-              <a:rPr lang="en-US" sz="2400">
+              <a:rPr lang="en-US" sz="2300">
                 <a:solidFill>
                   <a:schemeClr val="dk1"/>
                 </a:solidFill>
-                <a:latin typeface="Calibri"/>
-                <a:ea typeface="Calibri"/>
-                <a:cs typeface="Calibri"/>
-                <a:sym typeface="Calibri"/>
+                <a:latin typeface="Helvetica Neue Light"/>
+                <a:ea typeface="Helvetica Neue Light"/>
+                <a:cs typeface="Helvetica Neue Light"/>
+                <a:sym typeface="Helvetica Neue Light"/>
               </a:rPr>
               <a:t>Some of these art projects have been displayed in various local museums or on the ASU campus for short periods of time.  However, there has never been a physical museum experience showcasing every Psyche Inspired art piece in one place.  While all of the art pieces are available to view on the Psyche website, this does not give the same feeling of being in a museum.  Our team’s goal was to create a virtual reality museum that gave viewers the chance to experience Psyche Inspired art in the immersive museum setting that it deserves.</a:t>
             </a:r>
-            <a:endParaRPr sz="2400">
+            <a:endParaRPr sz="2300">
               <a:solidFill>
                 <a:schemeClr val="dk1"/>
               </a:solidFill>
-              <a:latin typeface="Calibri"/>
-              <a:ea typeface="Calibri"/>
-              <a:cs typeface="Calibri"/>
-              <a:sym typeface="Calibri"/>
+              <a:latin typeface="Helvetica Neue Light"/>
+              <a:ea typeface="Helvetica Neue Light"/>
+              <a:cs typeface="Helvetica Neue Light"/>
+              <a:sym typeface="Helvetica Neue Light"/>
             </a:endParaRPr>
           </a:p>
         </p:txBody>
@@ -13872,25 +14018,30 @@
           <p:cNvPicPr preferRelativeResize="0"/>
           <p:nvPr/>
         </p:nvPicPr>
-        <p:blipFill>
+        <p:blipFill rotWithShape="1">
           <a:blip r:embed="rId6">
             <a:alphaModFix/>
           </a:blip>
-          <a:stretch>
-            <a:fillRect/>
-          </a:stretch>
+          <a:srcRect b="3587" l="0" r="3223" t="0"/>
+          <a:stretch/>
         </p:blipFill>
         <p:spPr>
           <a:xfrm>
-            <a:off x="21618952" y="7977000"/>
-            <a:ext cx="9427500" cy="3753233"/>
+            <a:off x="22658650" y="15183554"/>
+            <a:ext cx="7348099" cy="4079100"/>
           </a:xfrm>
           <a:prstGeom prst="rect">
             <a:avLst/>
           </a:prstGeom>
           <a:noFill/>
-          <a:ln>
-            <a:noFill/>
+          <a:ln cap="flat" cmpd="sng" w="38100">
+            <a:solidFill>
+              <a:srgbClr val="302144"/>
+            </a:solidFill>
+            <a:prstDash val="solid"/>
+            <a:round/>
+            <a:headEnd len="sm" w="sm" type="none"/>
+            <a:tailEnd len="sm" w="sm" type="none"/>
           </a:ln>
         </p:spPr>
       </p:pic>
@@ -13904,20 +14055,26 @@
           <a:blip r:embed="rId7">
             <a:alphaModFix/>
           </a:blip>
-          <a:srcRect b="0" l="0" r="3223" t="0"/>
+          <a:srcRect b="4934" l="0" r="1778" t="0"/>
           <a:stretch/>
         </p:blipFill>
         <p:spPr>
           <a:xfrm>
-            <a:off x="21716650" y="14483963"/>
-            <a:ext cx="9427500" cy="5428176"/>
+            <a:off x="12888901" y="12478215"/>
+            <a:ext cx="6226201" cy="6571675"/>
           </a:xfrm>
           <a:prstGeom prst="rect">
             <a:avLst/>
           </a:prstGeom>
           <a:noFill/>
-          <a:ln>
-            <a:noFill/>
+          <a:ln cap="flat" cmpd="sng" w="38100">
+            <a:solidFill>
+              <a:srgbClr val="302144"/>
+            </a:solidFill>
+            <a:prstDash val="solid"/>
+            <a:round/>
+            <a:headEnd len="sm" w="sm" type="none"/>
+            <a:tailEnd len="sm" w="sm" type="none"/>
           </a:ln>
         </p:spPr>
       </p:pic>
@@ -13927,27 +14084,420 @@
           <p:cNvPicPr preferRelativeResize="0"/>
           <p:nvPr/>
         </p:nvPicPr>
-        <p:blipFill rotWithShape="1">
+        <p:blipFill>
           <a:blip r:embed="rId8">
             <a:alphaModFix/>
           </a:blip>
-          <a:srcRect b="4934" l="0" r="1778" t="0"/>
-          <a:stretch/>
+          <a:stretch>
+            <a:fillRect/>
+          </a:stretch>
         </p:blipFill>
         <p:spPr>
           <a:xfrm>
-            <a:off x="12746238" y="13425800"/>
-            <a:ext cx="6609225" cy="6975950"/>
+            <a:off x="23531137" y="8259373"/>
+            <a:ext cx="5603124" cy="5011101"/>
           </a:xfrm>
           <a:prstGeom prst="rect">
             <a:avLst/>
           </a:prstGeom>
           <a:noFill/>
-          <a:ln>
-            <a:noFill/>
+          <a:ln cap="flat" cmpd="sng" w="38100">
+            <a:solidFill>
+              <a:srgbClr val="302144"/>
+            </a:solidFill>
+            <a:prstDash val="solid"/>
+            <a:round/>
+            <a:headEnd len="sm" w="sm" type="none"/>
+            <a:tailEnd len="sm" w="sm" type="none"/>
           </a:ln>
         </p:spPr>
       </p:pic>
+      <p:sp>
+        <p:nvSpPr>
+          <p:cNvPr id="96" name="Google Shape;96;p1"/>
+          <p:cNvSpPr txBox="1"/>
+          <p:nvPr/>
+        </p:nvSpPr>
+        <p:spPr>
+          <a:xfrm>
+            <a:off x="22658700" y="19418025"/>
+            <a:ext cx="7348200" cy="831300"/>
+          </a:xfrm>
+          <a:prstGeom prst="rect">
+            <a:avLst/>
+          </a:prstGeom>
+          <a:solidFill>
+            <a:srgbClr val="F9A000"/>
+          </a:solidFill>
+          <a:ln cap="flat" cmpd="sng" w="76200">
+            <a:solidFill>
+              <a:srgbClr val="592651"/>
+            </a:solidFill>
+            <a:prstDash val="solid"/>
+            <a:round/>
+            <a:headEnd len="sm" w="sm" type="none"/>
+            <a:tailEnd len="sm" w="sm" type="none"/>
+          </a:ln>
+        </p:spPr>
+        <p:txBody>
+          <a:bodyPr anchorCtr="0" anchor="t" bIns="91425" lIns="91425" spcFirstLastPara="1" rIns="91425" wrap="square" tIns="91425">
+            <a:spAutoFit/>
+          </a:bodyPr>
+          <a:lstStyle/>
+          <a:p>
+            <a:pPr indent="0" lvl="0" marL="0" rtl="0" algn="ctr">
+              <a:spcBef>
+                <a:spcPts val="0"/>
+              </a:spcBef>
+              <a:spcAft>
+                <a:spcPts val="0"/>
+              </a:spcAft>
+              <a:buNone/>
+            </a:pPr>
+            <a:r>
+              <a:rPr lang="en-US">
+                <a:solidFill>
+                  <a:schemeClr val="dk1"/>
+                </a:solidFill>
+                <a:latin typeface="Helvetica Neue"/>
+                <a:ea typeface="Helvetica Neue"/>
+                <a:cs typeface="Helvetica Neue"/>
+                <a:sym typeface="Helvetica Neue"/>
+              </a:rPr>
+              <a:t>Figure 3: These decorations randomly populate empty spaces in the museum, making it feel more vivid.  A checking algorithm ensures that </a:t>
+            </a:r>
+            <a:r>
+              <a:rPr lang="en-US">
+                <a:solidFill>
+                  <a:schemeClr val="dk1"/>
+                </a:solidFill>
+                <a:latin typeface="Helvetica Neue"/>
+                <a:ea typeface="Helvetica Neue"/>
+                <a:cs typeface="Helvetica Neue"/>
+                <a:sym typeface="Helvetica Neue"/>
+              </a:rPr>
+              <a:t>identical</a:t>
+            </a:r>
+            <a:r>
+              <a:rPr lang="en-US">
+                <a:solidFill>
+                  <a:schemeClr val="dk1"/>
+                </a:solidFill>
+                <a:latin typeface="Helvetica Neue"/>
+                <a:ea typeface="Helvetica Neue"/>
+                <a:cs typeface="Helvetica Neue"/>
+                <a:sym typeface="Helvetica Neue"/>
+              </a:rPr>
+              <a:t> decorations do not appear in twice in the same room.</a:t>
+            </a:r>
+            <a:endParaRPr>
+              <a:solidFill>
+                <a:schemeClr val="dk1"/>
+              </a:solidFill>
+              <a:latin typeface="Helvetica Neue"/>
+              <a:ea typeface="Helvetica Neue"/>
+              <a:cs typeface="Helvetica Neue"/>
+              <a:sym typeface="Helvetica Neue"/>
+            </a:endParaRPr>
+          </a:p>
+        </p:txBody>
+      </p:sp>
+      <p:sp>
+        <p:nvSpPr>
+          <p:cNvPr id="97" name="Google Shape;97;p1"/>
+          <p:cNvSpPr txBox="1"/>
+          <p:nvPr/>
+        </p:nvSpPr>
+        <p:spPr>
+          <a:xfrm>
+            <a:off x="22581001" y="13425496"/>
+            <a:ext cx="7503600" cy="615600"/>
+          </a:xfrm>
+          <a:prstGeom prst="rect">
+            <a:avLst/>
+          </a:prstGeom>
+          <a:solidFill>
+            <a:srgbClr val="F9A000"/>
+          </a:solidFill>
+          <a:ln cap="flat" cmpd="sng" w="76200">
+            <a:solidFill>
+              <a:srgbClr val="592651"/>
+            </a:solidFill>
+            <a:prstDash val="solid"/>
+            <a:round/>
+            <a:headEnd len="sm" w="sm" type="none"/>
+            <a:tailEnd len="sm" w="sm" type="none"/>
+          </a:ln>
+        </p:spPr>
+        <p:txBody>
+          <a:bodyPr anchorCtr="0" anchor="t" bIns="91425" lIns="91425" spcFirstLastPara="1" rIns="91425" wrap="square" tIns="91425">
+            <a:spAutoFit/>
+          </a:bodyPr>
+          <a:lstStyle/>
+          <a:p>
+            <a:pPr indent="0" lvl="0" marL="0" rtl="0" algn="ctr">
+              <a:spcBef>
+                <a:spcPts val="0"/>
+              </a:spcBef>
+              <a:spcAft>
+                <a:spcPts val="0"/>
+              </a:spcAft>
+              <a:buNone/>
+            </a:pPr>
+            <a:r>
+              <a:rPr lang="en-US">
+                <a:solidFill>
+                  <a:schemeClr val="dk1"/>
+                </a:solidFill>
+                <a:latin typeface="Helvetica Neue"/>
+                <a:ea typeface="Helvetica Neue"/>
+                <a:cs typeface="Helvetica Neue"/>
+                <a:sym typeface="Helvetica Neue"/>
+              </a:rPr>
+              <a:t>Figure 2: Visualization of generated Room Chunks. Each room is connected to the next in a snake-like pattern, and each room is confined to its own chunk.</a:t>
+            </a:r>
+            <a:endParaRPr>
+              <a:solidFill>
+                <a:schemeClr val="dk1"/>
+              </a:solidFill>
+              <a:latin typeface="Helvetica Neue"/>
+              <a:ea typeface="Helvetica Neue"/>
+              <a:cs typeface="Helvetica Neue"/>
+              <a:sym typeface="Helvetica Neue"/>
+            </a:endParaRPr>
+          </a:p>
+        </p:txBody>
+      </p:sp>
+      <p:sp>
+        <p:nvSpPr>
+          <p:cNvPr id="98" name="Google Shape;98;p1"/>
+          <p:cNvSpPr txBox="1"/>
+          <p:nvPr/>
+        </p:nvSpPr>
+        <p:spPr>
+          <a:xfrm>
+            <a:off x="12250201" y="19187381"/>
+            <a:ext cx="7503600" cy="1046700"/>
+          </a:xfrm>
+          <a:prstGeom prst="rect">
+            <a:avLst/>
+          </a:prstGeom>
+          <a:solidFill>
+            <a:srgbClr val="F9A000"/>
+          </a:solidFill>
+          <a:ln cap="flat" cmpd="sng" w="76200">
+            <a:solidFill>
+              <a:srgbClr val="592651"/>
+            </a:solidFill>
+            <a:prstDash val="solid"/>
+            <a:round/>
+            <a:headEnd len="sm" w="sm" type="none"/>
+            <a:tailEnd len="sm" w="sm" type="none"/>
+          </a:ln>
+        </p:spPr>
+        <p:txBody>
+          <a:bodyPr anchorCtr="0" anchor="t" bIns="91425" lIns="91425" spcFirstLastPara="1" rIns="91425" wrap="square" tIns="91425">
+            <a:spAutoFit/>
+          </a:bodyPr>
+          <a:lstStyle/>
+          <a:p>
+            <a:pPr indent="0" lvl="0" marL="0" rtl="0" algn="ctr">
+              <a:spcBef>
+                <a:spcPts val="0"/>
+              </a:spcBef>
+              <a:spcAft>
+                <a:spcPts val="0"/>
+              </a:spcAft>
+              <a:buNone/>
+            </a:pPr>
+            <a:r>
+              <a:rPr lang="en-US">
+                <a:solidFill>
+                  <a:schemeClr val="dk1"/>
+                </a:solidFill>
+                <a:latin typeface="Helvetica Neue"/>
+                <a:ea typeface="Helvetica Neue"/>
+                <a:cs typeface="Helvetica Neue"/>
+                <a:sym typeface="Helvetica Neue"/>
+              </a:rPr>
+              <a:t>Figure 1: An art frame from the museum showing one of the Psyche Inspired art projects.  The artist information is shown on a plaque to the right of the frame.  Pressing a </a:t>
+            </a:r>
+            <a:r>
+              <a:rPr lang="en-US">
+                <a:solidFill>
+                  <a:schemeClr val="dk1"/>
+                </a:solidFill>
+                <a:latin typeface="Helvetica Neue"/>
+                <a:ea typeface="Helvetica Neue"/>
+                <a:cs typeface="Helvetica Neue"/>
+                <a:sym typeface="Helvetica Neue"/>
+              </a:rPr>
+              <a:t>button</a:t>
+            </a:r>
+            <a:r>
+              <a:rPr lang="en-US">
+                <a:solidFill>
+                  <a:schemeClr val="dk1"/>
+                </a:solidFill>
+                <a:latin typeface="Helvetica Neue"/>
+                <a:ea typeface="Helvetica Neue"/>
+                <a:cs typeface="Helvetica Neue"/>
+                <a:sym typeface="Helvetica Neue"/>
+              </a:rPr>
+              <a:t> next to the plaque will expand the plaque to show the full artist’s description.  A small light above the frame illuminates the frame with mood lighting.</a:t>
+            </a:r>
+            <a:endParaRPr>
+              <a:solidFill>
+                <a:schemeClr val="dk1"/>
+              </a:solidFill>
+              <a:latin typeface="Helvetica Neue"/>
+              <a:ea typeface="Helvetica Neue"/>
+              <a:cs typeface="Helvetica Neue"/>
+              <a:sym typeface="Helvetica Neue"/>
+            </a:endParaRPr>
+          </a:p>
+        </p:txBody>
+      </p:sp>
+      <p:sp>
+        <p:nvSpPr>
+          <p:cNvPr id="99" name="Google Shape;99;p1"/>
+          <p:cNvSpPr txBox="1"/>
+          <p:nvPr/>
+        </p:nvSpPr>
+        <p:spPr>
+          <a:xfrm>
+            <a:off x="957550" y="15062100"/>
+            <a:ext cx="9427500" cy="3370800"/>
+          </a:xfrm>
+          <a:prstGeom prst="rect">
+            <a:avLst/>
+          </a:prstGeom>
+          <a:solidFill>
+            <a:srgbClr val="F9A000"/>
+          </a:solidFill>
+          <a:ln cap="flat" cmpd="sng" w="76200">
+            <a:solidFill>
+              <a:srgbClr val="592651"/>
+            </a:solidFill>
+            <a:prstDash val="solid"/>
+            <a:round/>
+            <a:headEnd len="sm" w="sm" type="none"/>
+            <a:tailEnd len="sm" w="sm" type="none"/>
+          </a:ln>
+        </p:spPr>
+        <p:txBody>
+          <a:bodyPr anchorCtr="0" anchor="t" bIns="91425" lIns="91425" spcFirstLastPara="1" rIns="91425" wrap="square" tIns="91425">
+            <a:spAutoFit/>
+          </a:bodyPr>
+          <a:lstStyle/>
+          <a:p>
+            <a:pPr indent="0" lvl="0" marL="0" rtl="0" algn="l">
+              <a:spcBef>
+                <a:spcPts val="0"/>
+              </a:spcBef>
+              <a:spcAft>
+                <a:spcPts val="0"/>
+              </a:spcAft>
+              <a:buClr>
+                <a:schemeClr val="dk1"/>
+              </a:buClr>
+              <a:buSzPts val="1100"/>
+              <a:buFont typeface="Arial"/>
+              <a:buNone/>
+            </a:pPr>
+            <a:r>
+              <a:rPr lang="en-US" sz="4600">
+                <a:solidFill>
+                  <a:schemeClr val="dk1"/>
+                </a:solidFill>
+                <a:latin typeface="Helvetica Neue Light"/>
+                <a:ea typeface="Helvetica Neue Light"/>
+                <a:cs typeface="Helvetica Neue Light"/>
+                <a:sym typeface="Helvetica Neue Light"/>
+              </a:rPr>
+              <a:t>Artwork Display</a:t>
+            </a:r>
+            <a:endParaRPr sz="4600">
+              <a:solidFill>
+                <a:schemeClr val="dk1"/>
+              </a:solidFill>
+              <a:latin typeface="Helvetica Neue Light"/>
+              <a:ea typeface="Helvetica Neue Light"/>
+              <a:cs typeface="Helvetica Neue Light"/>
+              <a:sym typeface="Helvetica Neue Light"/>
+            </a:endParaRPr>
+          </a:p>
+          <a:p>
+            <a:pPr indent="0" lvl="0" marL="0" rtl="0" algn="l">
+              <a:spcBef>
+                <a:spcPts val="0"/>
+              </a:spcBef>
+              <a:spcAft>
+                <a:spcPts val="0"/>
+              </a:spcAft>
+              <a:buClr>
+                <a:schemeClr val="dk1"/>
+              </a:buClr>
+              <a:buSzPts val="1100"/>
+              <a:buFont typeface="Arial"/>
+              <a:buNone/>
+            </a:pPr>
+            <a:r>
+              <a:rPr lang="en-US" sz="2300">
+                <a:solidFill>
+                  <a:schemeClr val="dk1"/>
+                </a:solidFill>
+                <a:latin typeface="Helvetica Neue Light"/>
+                <a:ea typeface="Helvetica Neue Light"/>
+                <a:cs typeface="Helvetica Neue Light"/>
+                <a:sym typeface="Helvetica Neue Light"/>
+              </a:rPr>
+              <a:t>Each piece of artwork is displayed in high definition, with the artists Name, Major, Genre, Date of Creation, and a small description of the art piece. Clicking the small button to the right of the display brings out the full description of the art piece.</a:t>
+            </a:r>
+            <a:endParaRPr sz="2300">
+              <a:solidFill>
+                <a:schemeClr val="dk1"/>
+              </a:solidFill>
+              <a:latin typeface="Helvetica Neue Light"/>
+              <a:ea typeface="Helvetica Neue Light"/>
+              <a:cs typeface="Helvetica Neue Light"/>
+              <a:sym typeface="Helvetica Neue Light"/>
+            </a:endParaRPr>
+          </a:p>
+          <a:p>
+            <a:pPr indent="0" lvl="0" marL="0" rtl="0" algn="l">
+              <a:spcBef>
+                <a:spcPts val="0"/>
+              </a:spcBef>
+              <a:spcAft>
+                <a:spcPts val="0"/>
+              </a:spcAft>
+              <a:buNone/>
+            </a:pPr>
+            <a:r>
+              <a:rPr lang="en-US" sz="2300">
+                <a:solidFill>
+                  <a:schemeClr val="dk1"/>
+                </a:solidFill>
+                <a:latin typeface="Helvetica Neue Light"/>
+                <a:ea typeface="Helvetica Neue Light"/>
+                <a:cs typeface="Helvetica Neue Light"/>
+                <a:sym typeface="Helvetica Neue Light"/>
+              </a:rPr>
+              <a:t>Each tour of the museum contains a curated selection of displays from the database, providing each tour with its own unique set of art pieces. Videos and music</a:t>
+            </a:r>
+            <a:endParaRPr sz="4600">
+              <a:solidFill>
+                <a:schemeClr val="dk1"/>
+              </a:solidFill>
+              <a:latin typeface="Helvetica Neue Light"/>
+              <a:ea typeface="Helvetica Neue Light"/>
+              <a:cs typeface="Helvetica Neue Light"/>
+              <a:sym typeface="Helvetica Neue Light"/>
+            </a:endParaRPr>
+          </a:p>
+        </p:txBody>
+      </p:sp>
     </p:spTree>
   </p:cSld>
   <p:clrMapOvr>
@@ -13957,6 +14507,285 @@
 </file>
 
 <file path=ppt/theme/theme1.xml><?xml version="1.0" encoding="utf-8"?>
+<a:theme xmlns:a="http://schemas.openxmlformats.org/drawingml/2006/main" xmlns:r="http://schemas.openxmlformats.org/officeDocument/2006/relationships">
+  <a:themeElements>
+    <a:clrScheme name="Default">
+      <a:dk1>
+        <a:srgbClr val="000000"/>
+      </a:dk1>
+      <a:lt1>
+        <a:srgbClr val="FFFFFF"/>
+      </a:lt1>
+      <a:dk2>
+        <a:srgbClr val="158158"/>
+      </a:dk2>
+      <a:lt2>
+        <a:srgbClr val="F3F3F3"/>
+      </a:lt2>
+      <a:accent1>
+        <a:srgbClr val="058DC7"/>
+      </a:accent1>
+      <a:accent2>
+        <a:srgbClr val="50B432"/>
+      </a:accent2>
+      <a:accent3>
+        <a:srgbClr val="ED561B"/>
+      </a:accent3>
+      <a:accent4>
+        <a:srgbClr val="EDEF00"/>
+      </a:accent4>
+      <a:accent5>
+        <a:srgbClr val="24CBE5"/>
+      </a:accent5>
+      <a:accent6>
+        <a:srgbClr val="64E572"/>
+      </a:accent6>
+      <a:hlink>
+        <a:srgbClr val="2200CC"/>
+      </a:hlink>
+      <a:folHlink>
+        <a:srgbClr val="551A8B"/>
+      </a:folHlink>
+    </a:clrScheme>
+    <a:fontScheme name="Office">
+      <a:majorFont>
+        <a:latin typeface="Arial"/>
+        <a:ea typeface=""/>
+        <a:cs typeface=""/>
+        <a:font script="Jpan" typeface="ＭＳ Ｐゴシック"/>
+        <a:font script="Hang" typeface="맑은 고딕"/>
+        <a:font script="Hans" typeface="宋体"/>
+        <a:font script="Hant" typeface="新細明體"/>
+        <a:font script="Arab" typeface="Times New Roman"/>
+        <a:font script="Hebr" typeface="Times New Roman"/>
+        <a:font script="Thai" typeface="Angsana New"/>
+        <a:font script="Ethi" typeface="Nyala"/>
+        <a:font script="Beng" typeface="Vrinda"/>
+        <a:font script="Gujr" typeface="Shruti"/>
+        <a:font script="Khmr" typeface="MoolBoran"/>
+        <a:font script="Knda" typeface="Tunga"/>
+        <a:font script="Guru" typeface="Raavi"/>
+        <a:font script="Cans" typeface="Euphemia"/>
+        <a:font script="Cher" typeface="Plantagenet Cherokee"/>
+        <a:font script="Yiii" typeface="Microsoft Yi Baiti"/>
+        <a:font script="Tibt" typeface="Microsoft Himalaya"/>
+        <a:font script="Thaa" typeface="MV Boli"/>
+        <a:font script="Deva" typeface="Mangal"/>
+        <a:font script="Telu" typeface="Gautami"/>
+        <a:font script="Taml" typeface="Latha"/>
+        <a:font script="Syrc" typeface="Estrangelo Edessa"/>
+        <a:font script="Orya" typeface="Kalinga"/>
+        <a:font script="Mlym" typeface="Kartika"/>
+        <a:font script="Laoo" typeface="DokChampa"/>
+        <a:font script="Sinh" typeface="Iskoola Pota"/>
+        <a:font script="Mong" typeface="Mongolian Baiti"/>
+        <a:font script="Viet" typeface="Times New Roman"/>
+        <a:font script="Uigh" typeface="Microsoft Uighur"/>
+        <a:font script="Geor" typeface="Sylfaen"/>
+      </a:majorFont>
+      <a:minorFont>
+        <a:latin typeface="Arial"/>
+        <a:ea typeface=""/>
+        <a:cs typeface=""/>
+        <a:font script="Jpan" typeface="ＭＳ Ｐゴシック"/>
+        <a:font script="Hang" typeface="맑은 고딕"/>
+        <a:font script="Hans" typeface="宋体"/>
+        <a:font script="Hant" typeface="新細明體"/>
+        <a:font script="Arab" typeface="Arial"/>
+        <a:font script="Hebr" typeface="Arial"/>
+        <a:font script="Thai" typeface="Cordia New"/>
+        <a:font script="Ethi" typeface="Nyala"/>
+        <a:font script="Beng" typeface="Vrinda"/>
+        <a:font script="Gujr" typeface="Shruti"/>
+        <a:font script="Khmr" typeface="DaunPenh"/>
+        <a:font script="Knda" typeface="Tunga"/>
+        <a:font script="Guru" typeface="Raavi"/>
+        <a:font script="Cans" typeface="Euphemia"/>
+        <a:font script="Cher" typeface="Plantagenet Cherokee"/>
+        <a:font script="Yiii" typeface="Microsoft Yi Baiti"/>
+        <a:font script="Tibt" typeface="Microsoft Himalaya"/>
+        <a:font script="Thaa" typeface="MV Boli"/>
+        <a:font script="Deva" typeface="Mangal"/>
+        <a:font script="Telu" typeface="Gautami"/>
+        <a:font script="Taml" typeface="Latha"/>
+        <a:font script="Syrc" typeface="Estrangelo Edessa"/>
+        <a:font script="Orya" typeface="Kalinga"/>
+        <a:font script="Mlym" typeface="Kartika"/>
+        <a:font script="Laoo" typeface="DokChampa"/>
+        <a:font script="Sinh" typeface="Iskoola Pota"/>
+        <a:font script="Mong" typeface="Mongolian Baiti"/>
+        <a:font script="Viet" typeface="Arial"/>
+        <a:font script="Uigh" typeface="Microsoft Uighur"/>
+        <a:font script="Geor" typeface="Sylfaen"/>
+      </a:minorFont>
+    </a:fontScheme>
+    <a:fmtScheme name="Office">
+      <a:fillStyleLst>
+        <a:solidFill>
+          <a:schemeClr val="phClr"/>
+        </a:solidFill>
+        <a:gradFill rotWithShape="1">
+          <a:gsLst>
+            <a:gs pos="0">
+              <a:schemeClr val="phClr">
+                <a:tint val="50000"/>
+                <a:satMod val="300000"/>
+              </a:schemeClr>
+            </a:gs>
+            <a:gs pos="35000">
+              <a:schemeClr val="phClr">
+                <a:tint val="37000"/>
+                <a:satMod val="300000"/>
+              </a:schemeClr>
+            </a:gs>
+            <a:gs pos="100000">
+              <a:schemeClr val="phClr">
+                <a:tint val="15000"/>
+                <a:satMod val="350000"/>
+              </a:schemeClr>
+            </a:gs>
+          </a:gsLst>
+          <a:lin ang="16200000" scaled="1"/>
+        </a:gradFill>
+        <a:gradFill rotWithShape="1">
+          <a:gsLst>
+            <a:gs pos="0">
+              <a:schemeClr val="phClr">
+                <a:tint val="100000"/>
+                <a:shade val="100000"/>
+                <a:satMod val="130000"/>
+              </a:schemeClr>
+            </a:gs>
+            <a:gs pos="100000">
+              <a:schemeClr val="phClr">
+                <a:tint val="50000"/>
+                <a:shade val="100000"/>
+                <a:satMod val="350000"/>
+              </a:schemeClr>
+            </a:gs>
+          </a:gsLst>
+          <a:lin ang="16200000" scaled="0"/>
+        </a:gradFill>
+      </a:fillStyleLst>
+      <a:lnStyleLst>
+        <a:ln w="9525" cap="flat" cmpd="sng" algn="ctr">
+          <a:solidFill>
+            <a:schemeClr val="phClr">
+              <a:shade val="95000"/>
+              <a:satMod val="105000"/>
+            </a:schemeClr>
+          </a:solidFill>
+          <a:prstDash val="solid"/>
+        </a:ln>
+        <a:ln w="25400" cap="flat" cmpd="sng" algn="ctr">
+          <a:solidFill>
+            <a:schemeClr val="phClr"/>
+          </a:solidFill>
+          <a:prstDash val="solid"/>
+        </a:ln>
+        <a:ln w="38100" cap="flat" cmpd="sng" algn="ctr">
+          <a:solidFill>
+            <a:schemeClr val="phClr"/>
+          </a:solidFill>
+          <a:prstDash val="solid"/>
+        </a:ln>
+      </a:lnStyleLst>
+      <a:effectStyleLst>
+        <a:effectStyle>
+          <a:effectLst>
+            <a:outerShdw blurRad="40000" dist="20000" dir="5400000" rotWithShape="0">
+              <a:srgbClr val="000000">
+                <a:alpha val="38000"/>
+              </a:srgbClr>
+            </a:outerShdw>
+          </a:effectLst>
+        </a:effectStyle>
+        <a:effectStyle>
+          <a:effectLst>
+            <a:outerShdw blurRad="40000" dist="23000" dir="5400000" rotWithShape="0">
+              <a:srgbClr val="000000">
+                <a:alpha val="35000"/>
+              </a:srgbClr>
+            </a:outerShdw>
+          </a:effectLst>
+        </a:effectStyle>
+        <a:effectStyle>
+          <a:effectLst>
+            <a:outerShdw blurRad="40000" dist="23000" dir="5400000" rotWithShape="0">
+              <a:srgbClr val="000000">
+                <a:alpha val="35000"/>
+              </a:srgbClr>
+            </a:outerShdw>
+          </a:effectLst>
+          <a:scene3d>
+            <a:camera prst="orthographicFront">
+              <a:rot lat="0" lon="0" rev="0"/>
+            </a:camera>
+            <a:lightRig rig="threePt" dir="t">
+              <a:rot lat="0" lon="0" rev="1200000"/>
+            </a:lightRig>
+          </a:scene3d>
+          <a:sp3d>
+            <a:bevelT w="63500" h="25400"/>
+          </a:sp3d>
+        </a:effectStyle>
+      </a:effectStyleLst>
+      <a:bgFillStyleLst>
+        <a:solidFill>
+          <a:schemeClr val="phClr"/>
+        </a:solidFill>
+        <a:gradFill rotWithShape="1">
+          <a:gsLst>
+            <a:gs pos="0">
+              <a:schemeClr val="phClr">
+                <a:tint val="40000"/>
+                <a:satMod val="350000"/>
+              </a:schemeClr>
+            </a:gs>
+            <a:gs pos="40000">
+              <a:schemeClr val="phClr">
+                <a:tint val="45000"/>
+                <a:shade val="99000"/>
+                <a:satMod val="350000"/>
+              </a:schemeClr>
+            </a:gs>
+            <a:gs pos="100000">
+              <a:schemeClr val="phClr">
+                <a:shade val="20000"/>
+                <a:satMod val="255000"/>
+              </a:schemeClr>
+            </a:gs>
+          </a:gsLst>
+          <a:path path="circle">
+            <a:fillToRect l="50000" t="-80000" r="50000" b="180000"/>
+          </a:path>
+        </a:gradFill>
+        <a:gradFill rotWithShape="1">
+          <a:gsLst>
+            <a:gs pos="0">
+              <a:schemeClr val="phClr">
+                <a:tint val="80000"/>
+                <a:satMod val="300000"/>
+              </a:schemeClr>
+            </a:gs>
+            <a:gs pos="100000">
+              <a:schemeClr val="phClr">
+                <a:shade val="30000"/>
+                <a:satMod val="200000"/>
+              </a:schemeClr>
+            </a:gs>
+          </a:gsLst>
+          <a:path path="circle">
+            <a:fillToRect l="50000" t="50000" r="50000" b="50000"/>
+          </a:path>
+        </a:gradFill>
+      </a:bgFillStyleLst>
+    </a:fmtScheme>
+  </a:themeElements>
+</a:theme>
+</file>
+
+<file path=ppt/theme/theme2.xml><?xml version="1.0" encoding="utf-8"?>
 <a:theme xmlns:a="http://schemas.openxmlformats.org/drawingml/2006/main" xmlns:r="http://schemas.openxmlformats.org/officeDocument/2006/relationships" name="Office Theme">
   <a:themeElements>
     <a:clrScheme name="Office">
@@ -14233,283 +15062,4 @@
     </a:fmtScheme>
   </a:themeElements>
 </a:theme>
-</file>
-
-<file path=ppt/theme/theme2.xml><?xml version="1.0" encoding="utf-8"?>
-<a:theme xmlns:a="http://schemas.openxmlformats.org/drawingml/2006/main" xmlns:r="http://schemas.openxmlformats.org/officeDocument/2006/relationships">
-  <a:themeElements>
-    <a:clrScheme name="Default">
-      <a:dk1>
-        <a:srgbClr val="000000"/>
-      </a:dk1>
-      <a:lt1>
-        <a:srgbClr val="FFFFFF"/>
-      </a:lt1>
-      <a:dk2>
-        <a:srgbClr val="158158"/>
-      </a:dk2>
-      <a:lt2>
-        <a:srgbClr val="F3F3F3"/>
-      </a:lt2>
-      <a:accent1>
-        <a:srgbClr val="058DC7"/>
-      </a:accent1>
-      <a:accent2>
-        <a:srgbClr val="50B432"/>
-      </a:accent2>
-      <a:accent3>
-        <a:srgbClr val="ED561B"/>
-      </a:accent3>
-      <a:accent4>
-        <a:srgbClr val="EDEF00"/>
-      </a:accent4>
-      <a:accent5>
-        <a:srgbClr val="24CBE5"/>
-      </a:accent5>
-      <a:accent6>
-        <a:srgbClr val="64E572"/>
-      </a:accent6>
-      <a:hlink>
-        <a:srgbClr val="2200CC"/>
-      </a:hlink>
-      <a:folHlink>
-        <a:srgbClr val="551A8B"/>
-      </a:folHlink>
-    </a:clrScheme>
-    <a:fontScheme name="Office">
-      <a:majorFont>
-        <a:latin typeface="Arial"/>
-        <a:ea typeface=""/>
-        <a:cs typeface=""/>
-        <a:font script="Jpan" typeface="ＭＳ Ｐゴシック"/>
-        <a:font script="Hang" typeface="맑은 고딕"/>
-        <a:font script="Hans" typeface="宋体"/>
-        <a:font script="Hant" typeface="新細明體"/>
-        <a:font script="Arab" typeface="Times New Roman"/>
-        <a:font script="Hebr" typeface="Times New Roman"/>
-        <a:font script="Thai" typeface="Angsana New"/>
-        <a:font script="Ethi" typeface="Nyala"/>
-        <a:font script="Beng" typeface="Vrinda"/>
-        <a:font script="Gujr" typeface="Shruti"/>
-        <a:font script="Khmr" typeface="MoolBoran"/>
-        <a:font script="Knda" typeface="Tunga"/>
-        <a:font script="Guru" typeface="Raavi"/>
-        <a:font script="Cans" typeface="Euphemia"/>
-        <a:font script="Cher" typeface="Plantagenet Cherokee"/>
-        <a:font script="Yiii" typeface="Microsoft Yi Baiti"/>
-        <a:font script="Tibt" typeface="Microsoft Himalaya"/>
-        <a:font script="Thaa" typeface="MV Boli"/>
-        <a:font script="Deva" typeface="Mangal"/>
-        <a:font script="Telu" typeface="Gautami"/>
-        <a:font script="Taml" typeface="Latha"/>
-        <a:font script="Syrc" typeface="Estrangelo Edessa"/>
-        <a:font script="Orya" typeface="Kalinga"/>
-        <a:font script="Mlym" typeface="Kartika"/>
-        <a:font script="Laoo" typeface="DokChampa"/>
-        <a:font script="Sinh" typeface="Iskoola Pota"/>
-        <a:font script="Mong" typeface="Mongolian Baiti"/>
-        <a:font script="Viet" typeface="Times New Roman"/>
-        <a:font script="Uigh" typeface="Microsoft Uighur"/>
-        <a:font script="Geor" typeface="Sylfaen"/>
-      </a:majorFont>
-      <a:minorFont>
-        <a:latin typeface="Arial"/>
-        <a:ea typeface=""/>
-        <a:cs typeface=""/>
-        <a:font script="Jpan" typeface="ＭＳ Ｐゴシック"/>
-        <a:font script="Hang" typeface="맑은 고딕"/>
-        <a:font script="Hans" typeface="宋体"/>
-        <a:font script="Hant" typeface="新細明體"/>
-        <a:font script="Arab" typeface="Arial"/>
-        <a:font script="Hebr" typeface="Arial"/>
-        <a:font script="Thai" typeface="Cordia New"/>
-        <a:font script="Ethi" typeface="Nyala"/>
-        <a:font script="Beng" typeface="Vrinda"/>
-        <a:font script="Gujr" typeface="Shruti"/>
-        <a:font script="Khmr" typeface="DaunPenh"/>
-        <a:font script="Knda" typeface="Tunga"/>
-        <a:font script="Guru" typeface="Raavi"/>
-        <a:font script="Cans" typeface="Euphemia"/>
-        <a:font script="Cher" typeface="Plantagenet Cherokee"/>
-        <a:font script="Yiii" typeface="Microsoft Yi Baiti"/>
-        <a:font script="Tibt" typeface="Microsoft Himalaya"/>
-        <a:font script="Thaa" typeface="MV Boli"/>
-        <a:font script="Deva" typeface="Mangal"/>
-        <a:font script="Telu" typeface="Gautami"/>
-        <a:font script="Taml" typeface="Latha"/>
-        <a:font script="Syrc" typeface="Estrangelo Edessa"/>
-        <a:font script="Orya" typeface="Kalinga"/>
-        <a:font script="Mlym" typeface="Kartika"/>
-        <a:font script="Laoo" typeface="DokChampa"/>
-        <a:font script="Sinh" typeface="Iskoola Pota"/>
-        <a:font script="Mong" typeface="Mongolian Baiti"/>
-        <a:font script="Viet" typeface="Arial"/>
-        <a:font script="Uigh" typeface="Microsoft Uighur"/>
-        <a:font script="Geor" typeface="Sylfaen"/>
-      </a:minorFont>
-    </a:fontScheme>
-    <a:fmtScheme name="Office">
-      <a:fillStyleLst>
-        <a:solidFill>
-          <a:schemeClr val="phClr"/>
-        </a:solidFill>
-        <a:gradFill rotWithShape="1">
-          <a:gsLst>
-            <a:gs pos="0">
-              <a:schemeClr val="phClr">
-                <a:tint val="50000"/>
-                <a:satMod val="300000"/>
-              </a:schemeClr>
-            </a:gs>
-            <a:gs pos="35000">
-              <a:schemeClr val="phClr">
-                <a:tint val="37000"/>
-                <a:satMod val="300000"/>
-              </a:schemeClr>
-            </a:gs>
-            <a:gs pos="100000">
-              <a:schemeClr val="phClr">
-                <a:tint val="15000"/>
-                <a:satMod val="350000"/>
-              </a:schemeClr>
-            </a:gs>
-          </a:gsLst>
-          <a:lin ang="16200000" scaled="1"/>
-        </a:gradFill>
-        <a:gradFill rotWithShape="1">
-          <a:gsLst>
-            <a:gs pos="0">
-              <a:schemeClr val="phClr">
-                <a:tint val="100000"/>
-                <a:shade val="100000"/>
-                <a:satMod val="130000"/>
-              </a:schemeClr>
-            </a:gs>
-            <a:gs pos="100000">
-              <a:schemeClr val="phClr">
-                <a:tint val="50000"/>
-                <a:shade val="100000"/>
-                <a:satMod val="350000"/>
-              </a:schemeClr>
-            </a:gs>
-          </a:gsLst>
-          <a:lin ang="16200000" scaled="0"/>
-        </a:gradFill>
-      </a:fillStyleLst>
-      <a:lnStyleLst>
-        <a:ln w="9525" cap="flat" cmpd="sng" algn="ctr">
-          <a:solidFill>
-            <a:schemeClr val="phClr">
-              <a:shade val="95000"/>
-              <a:satMod val="105000"/>
-            </a:schemeClr>
-          </a:solidFill>
-          <a:prstDash val="solid"/>
-        </a:ln>
-        <a:ln w="25400" cap="flat" cmpd="sng" algn="ctr">
-          <a:solidFill>
-            <a:schemeClr val="phClr"/>
-          </a:solidFill>
-          <a:prstDash val="solid"/>
-        </a:ln>
-        <a:ln w="38100" cap="flat" cmpd="sng" algn="ctr">
-          <a:solidFill>
-            <a:schemeClr val="phClr"/>
-          </a:solidFill>
-          <a:prstDash val="solid"/>
-        </a:ln>
-      </a:lnStyleLst>
-      <a:effectStyleLst>
-        <a:effectStyle>
-          <a:effectLst>
-            <a:outerShdw blurRad="40000" dist="20000" dir="5400000" rotWithShape="0">
-              <a:srgbClr val="000000">
-                <a:alpha val="38000"/>
-              </a:srgbClr>
-            </a:outerShdw>
-          </a:effectLst>
-        </a:effectStyle>
-        <a:effectStyle>
-          <a:effectLst>
-            <a:outerShdw blurRad="40000" dist="23000" dir="5400000" rotWithShape="0">
-              <a:srgbClr val="000000">
-                <a:alpha val="35000"/>
-              </a:srgbClr>
-            </a:outerShdw>
-          </a:effectLst>
-        </a:effectStyle>
-        <a:effectStyle>
-          <a:effectLst>
-            <a:outerShdw blurRad="40000" dist="23000" dir="5400000" rotWithShape="0">
-              <a:srgbClr val="000000">
-                <a:alpha val="35000"/>
-              </a:srgbClr>
-            </a:outerShdw>
-          </a:effectLst>
-          <a:scene3d>
-            <a:camera prst="orthographicFront">
-              <a:rot lat="0" lon="0" rev="0"/>
-            </a:camera>
-            <a:lightRig rig="threePt" dir="t">
-              <a:rot lat="0" lon="0" rev="1200000"/>
-            </a:lightRig>
-          </a:scene3d>
-          <a:sp3d>
-            <a:bevelT w="63500" h="25400"/>
-          </a:sp3d>
-        </a:effectStyle>
-      </a:effectStyleLst>
-      <a:bgFillStyleLst>
-        <a:solidFill>
-          <a:schemeClr val="phClr"/>
-        </a:solidFill>
-        <a:gradFill rotWithShape="1">
-          <a:gsLst>
-            <a:gs pos="0">
-              <a:schemeClr val="phClr">
-                <a:tint val="40000"/>
-                <a:satMod val="350000"/>
-              </a:schemeClr>
-            </a:gs>
-            <a:gs pos="40000">
-              <a:schemeClr val="phClr">
-                <a:tint val="45000"/>
-                <a:shade val="99000"/>
-                <a:satMod val="350000"/>
-              </a:schemeClr>
-            </a:gs>
-            <a:gs pos="100000">
-              <a:schemeClr val="phClr">
-                <a:shade val="20000"/>
-                <a:satMod val="255000"/>
-              </a:schemeClr>
-            </a:gs>
-          </a:gsLst>
-          <a:path path="circle">
-            <a:fillToRect l="50000" t="-80000" r="50000" b="180000"/>
-          </a:path>
-        </a:gradFill>
-        <a:gradFill rotWithShape="1">
-          <a:gsLst>
-            <a:gs pos="0">
-              <a:schemeClr val="phClr">
-                <a:tint val="80000"/>
-                <a:satMod val="300000"/>
-              </a:schemeClr>
-            </a:gs>
-            <a:gs pos="100000">
-              <a:schemeClr val="phClr">
-                <a:shade val="30000"/>
-                <a:satMod val="200000"/>
-              </a:schemeClr>
-            </a:gs>
-          </a:gsLst>
-          <a:path path="circle">
-            <a:fillToRect l="50000" t="50000" r="50000" b="50000"/>
-          </a:path>
-        </a:gradFill>
-      </a:bgFillStyleLst>
-    </a:fmtScheme>
-  </a:themeElements>
-</a:theme>
 </file>
</xml_diff>